<commit_message>
test(pptx-deck): add demo_plan.json end-to-end smoke
</commit_message>
<xml_diff>
--- a/skills/pptx-deck/examples/sample_output.pptx
+++ b/skills/pptx-deck/examples/sample_output.pptx
@@ -13,10 +13,6 @@
     <p:sldId id="261" r:id="rId12"/>
     <p:sldId id="262" r:id="rId13"/>
     <p:sldId id="263" r:id="rId14"/>
-    <p:sldId id="264" r:id="rId15"/>
-    <p:sldId id="265" r:id="rId16"/>
-    <p:sldId id="266" r:id="rId17"/>
-    <p:sldId id="267" r:id="rId18"/>
   </p:sldIdLst>
   <p:sldSz cx="12191695" cy="6858000" type="screen4x3"/>
   <p:notesSz cx="6858000" cy="9144000"/>
@@ -3150,8 +3146,8 @@
         </p:nvSpPr>
         <p:spPr>
           <a:xfrm>
-            <a:off x="502920" y="2560320"/>
-            <a:ext cx="10972800" cy="1645920"/>
+            <a:off x="502920" y="2834640"/>
+            <a:ext cx="11185855" cy="1097280"/>
           </a:xfrm>
           <a:prstGeom prst="rect">
             <a:avLst/>
@@ -3159,13 +3155,14 @@
           <a:noFill/>
         </p:spPr>
         <p:txBody>
-          <a:bodyPr wrap="none" lIns="0" rIns="0" tIns="0" bIns="0">
+          <a:bodyPr wrap="square" lIns="0" rIns="0" tIns="0" bIns="0">
             <a:spAutoFit/>
           </a:bodyPr>
           <a:lstStyle/>
           <a:p>
-            <a:r>
-              <a:rPr sz="4800" b="1" i="0">
+            <a:pPr algn="l"/>
+            <a:r>
+              <a:rPr sz="4400" b="1" i="0">
                 <a:solidFill>
                   <a:srgbClr val="FFFFFF"/>
                 </a:solidFill>
@@ -3173,7 +3170,7 @@
                 <a:ea typeface="Microsoft YaHei"/>
                 <a:cs typeface="Microsoft YaHei"/>
               </a:rPr>
-              <a:t>iLovePPT 自动化 PPT 生成</a:t>
+              <a:t>iLovePPT v2 演示</a:t>
             </a:r>
           </a:p>
         </p:txBody>
@@ -3187,7 +3184,7 @@
         <p:spPr>
           <a:xfrm>
             <a:off x="502920" y="4206240"/>
-            <a:ext cx="10972800" cy="731520"/>
+            <a:ext cx="11185855" cy="640080"/>
           </a:xfrm>
           <a:prstGeom prst="rect">
             <a:avLst/>
@@ -3195,11 +3192,12 @@
           <a:noFill/>
         </p:spPr>
         <p:txBody>
-          <a:bodyPr wrap="none" lIns="0" rIns="0" tIns="0" bIns="0">
+          <a:bodyPr wrap="square" lIns="0" rIns="0" tIns="0" bIns="0">
             <a:spAutoFit/>
           </a:bodyPr>
           <a:lstStyle/>
           <a:p>
+            <a:pPr algn="l"/>
             <a:r>
               <a:rPr sz="2000" b="0" i="0">
                 <a:solidFill>
@@ -3209,708 +3207,7 @@
                 <a:ea typeface="Microsoft YaHei"/>
                 <a:cs typeface="Microsoft YaHei"/>
               </a:rPr>
-              <a:t>demo brief 跑通整条 pipeline</a:t>
-            </a:r>
-          </a:p>
-        </p:txBody>
-      </p:sp>
-    </p:spTree>
-  </p:cSld>
-  <p:clrMapOvr>
-    <a:masterClrMapping/>
-  </p:clrMapOvr>
-</p:sld>
-</file>
-
-<file path=ppt/slides/slide10.xml><?xml version="1.0" encoding="utf-8"?>
-<p:sld xmlns:a="http://schemas.openxmlformats.org/drawingml/2006/main" xmlns:p="http://schemas.openxmlformats.org/presentationml/2006/main" xmlns:r="http://schemas.openxmlformats.org/officeDocument/2006/relationships">
-  <p:cSld>
-    <p:spTree>
-      <p:nvGrpSpPr>
-        <p:cNvPr id="1" name=""/>
-        <p:cNvGrpSpPr/>
-        <p:nvPr/>
-      </p:nvGrpSpPr>
-      <p:grpSpPr/>
-      <p:sp>
-        <p:nvSpPr>
-          <p:cNvPr id="2" name="TextBox 1"/>
-          <p:cNvSpPr txBox="1"/>
-          <p:nvPr/>
-        </p:nvSpPr>
-        <p:spPr>
-          <a:xfrm>
-            <a:off x="502920" y="548640"/>
-            <a:ext cx="11155680" cy="731520"/>
-          </a:xfrm>
-          <a:prstGeom prst="rect">
-            <a:avLst/>
-          </a:prstGeom>
-          <a:noFill/>
-        </p:spPr>
-        <p:txBody>
-          <a:bodyPr wrap="none" lIns="0" rIns="0" tIns="0" bIns="0">
-            <a:spAutoFit/>
-          </a:bodyPr>
-          <a:lstStyle/>
-          <a:p>
-            <a:r>
-              <a:rPr sz="2800" b="1" i="0">
-                <a:solidFill>
-                  <a:srgbClr val="0B2A4A"/>
-                </a:solidFill>
-                <a:latin typeface="Microsoft YaHei"/>
-                <a:ea typeface="Microsoft YaHei"/>
-                <a:cs typeface="Microsoft YaHei"/>
-              </a:rPr>
-              <a:t>落地路径</a:t>
-            </a:r>
-          </a:p>
-        </p:txBody>
-      </p:sp>
-      <p:sp>
-        <p:nvSpPr>
-          <p:cNvPr id="3" name="TextBox 2"/>
-          <p:cNvSpPr txBox="1"/>
-          <p:nvPr/>
-        </p:nvSpPr>
-        <p:spPr>
-          <a:xfrm>
-            <a:off x="502920" y="1645920"/>
-            <a:ext cx="11155680" cy="4754880"/>
-          </a:xfrm>
-          <a:prstGeom prst="rect">
-            <a:avLst/>
-          </a:prstGeom>
-          <a:noFill/>
-        </p:spPr>
-        <p:txBody>
-          <a:bodyPr wrap="square" lIns="0" rIns="0" tIns="0" bIns="0">
-            <a:spAutoFit/>
-          </a:bodyPr>
-          <a:lstStyle/>
-          <a:p>
-            <a:pPr>
-              <a:lnSpc>
-                <a:spcPct val="145000"/>
-              </a:lnSpc>
-            </a:pPr>
-            <a:r>
-              <a:rPr sz="1600" b="1" i="0">
-                <a:solidFill>
-                  <a:srgbClr val="1E6FE0"/>
-                </a:solidFill>
-                <a:latin typeface="Microsoft YaHei"/>
-                <a:ea typeface="Microsoft YaHei"/>
-                <a:cs typeface="Microsoft YaHei"/>
-              </a:rPr>
-              <a:t>▎ </a:t>
-            </a:r>
-            <a:r>
-              <a:rPr sz="1600" b="0" i="0">
-                <a:solidFill>
-                  <a:srgbClr val="1A1A1A"/>
-                </a:solidFill>
-                <a:latin typeface="Microsoft YaHei"/>
-                <a:ea typeface="Microsoft YaHei"/>
-                <a:cs typeface="Microsoft YaHei"/>
-              </a:rPr>
-              <a:t>5 分钟生成一份完整 deck</a:t>
-            </a:r>
-          </a:p>
-          <a:p>
-            <a:pPr>
-              <a:lnSpc>
-                <a:spcPct val="145000"/>
-              </a:lnSpc>
-            </a:pPr>
-            <a:r>
-              <a:rPr sz="1600" b="1" i="0">
-                <a:solidFill>
-                  <a:srgbClr val="1E6FE0"/>
-                </a:solidFill>
-                <a:latin typeface="Microsoft YaHei"/>
-                <a:ea typeface="Microsoft YaHei"/>
-                <a:cs typeface="Microsoft YaHei"/>
-              </a:rPr>
-              <a:t>▎ </a:t>
-            </a:r>
-            <a:r>
-              <a:rPr sz="1600" b="0" i="0">
-                <a:solidFill>
-                  <a:srgbClr val="1A1A1A"/>
-                </a:solidFill>
-                <a:latin typeface="Microsoft YaHei"/>
-                <a:ea typeface="Microsoft YaHei"/>
-                <a:cs typeface="Microsoft YaHei"/>
-              </a:rPr>
-              <a:t>视觉自检 + 自动修复</a:t>
-            </a:r>
-          </a:p>
-          <a:p>
-            <a:pPr>
-              <a:lnSpc>
-                <a:spcPct val="145000"/>
-              </a:lnSpc>
-            </a:pPr>
-            <a:r>
-              <a:rPr sz="1600" b="1" i="0">
-                <a:solidFill>
-                  <a:srgbClr val="1E6FE0"/>
-                </a:solidFill>
-                <a:latin typeface="Microsoft YaHei"/>
-                <a:ea typeface="Microsoft YaHei"/>
-                <a:cs typeface="Microsoft YaHei"/>
-              </a:rPr>
-              <a:t>▎ </a:t>
-            </a:r>
-            <a:r>
-              <a:rPr sz="1600" b="0" i="0">
-                <a:solidFill>
-                  <a:srgbClr val="1A1A1A"/>
-                </a:solidFill>
-                <a:latin typeface="Microsoft YaHei"/>
-                <a:ea typeface="Microsoft YaHei"/>
-                <a:cs typeface="Microsoft YaHei"/>
-              </a:rPr>
-              <a:t>支持模板学风格</a:t>
-            </a:r>
-          </a:p>
-        </p:txBody>
-      </p:sp>
-    </p:spTree>
-  </p:cSld>
-  <p:clrMapOvr>
-    <a:masterClrMapping/>
-  </p:clrMapOvr>
-</p:sld>
-</file>
-
-<file path=ppt/slides/slide11.xml><?xml version="1.0" encoding="utf-8"?>
-<p:sld xmlns:a="http://schemas.openxmlformats.org/drawingml/2006/main" xmlns:p="http://schemas.openxmlformats.org/presentationml/2006/main" xmlns:r="http://schemas.openxmlformats.org/officeDocument/2006/relationships">
-  <p:cSld>
-    <p:spTree>
-      <p:nvGrpSpPr>
-        <p:cNvPr id="1" name=""/>
-        <p:cNvGrpSpPr/>
-        <p:nvPr/>
-      </p:nvGrpSpPr>
-      <p:grpSpPr/>
-      <p:sp>
-        <p:nvSpPr>
-          <p:cNvPr id="2" name="TextBox 1"/>
-          <p:cNvSpPr txBox="1"/>
-          <p:nvPr/>
-        </p:nvSpPr>
-        <p:spPr>
-          <a:xfrm>
-            <a:off x="502920" y="548640"/>
-            <a:ext cx="11155680" cy="731520"/>
-          </a:xfrm>
-          <a:prstGeom prst="rect">
-            <a:avLst/>
-          </a:prstGeom>
-          <a:noFill/>
-        </p:spPr>
-        <p:txBody>
-          <a:bodyPr wrap="none" lIns="0" rIns="0" tIns="0" bIns="0">
-            <a:spAutoFit/>
-          </a:bodyPr>
-          <a:lstStyle/>
-          <a:p>
-            <a:r>
-              <a:rPr sz="3200" b="1" i="0">
-                <a:solidFill>
-                  <a:srgbClr val="0B2A4A"/>
-                </a:solidFill>
-                <a:latin typeface="Microsoft YaHei"/>
-                <a:ea typeface="Microsoft YaHei"/>
-                <a:cs typeface="Microsoft YaHei"/>
-              </a:rPr>
-              <a:t>核心结论</a:t>
-            </a:r>
-          </a:p>
-        </p:txBody>
-      </p:sp>
-      <p:sp>
-        <p:nvSpPr>
-          <p:cNvPr id="3" name="Rectangle 2"/>
-          <p:cNvSpPr/>
-          <p:nvPr/>
-        </p:nvSpPr>
-        <p:spPr>
-          <a:xfrm>
-            <a:off x="502920" y="1737360"/>
-            <a:ext cx="822960" cy="777240"/>
-          </a:xfrm>
-          <a:prstGeom prst="rect">
-            <a:avLst/>
-          </a:prstGeom>
-          <a:solidFill>
-            <a:srgbClr val="1E6FE0"/>
-          </a:solidFill>
-          <a:ln>
-            <a:noFill/>
-          </a:ln>
-        </p:spPr>
-        <p:style>
-          <a:lnRef idx="1">
-            <a:schemeClr val="accent1"/>
-          </a:lnRef>
-          <a:fillRef idx="3">
-            <a:schemeClr val="accent1"/>
-          </a:fillRef>
-          <a:effectRef idx="2">
-            <a:schemeClr val="accent1"/>
-          </a:effectRef>
-          <a:fontRef idx="minor">
-            <a:schemeClr val="lt1"/>
-          </a:fontRef>
-        </p:style>
-        <p:txBody>
-          <a:bodyPr rtlCol="0" anchor="ctr"/>
-          <a:lstStyle/>
-          <a:p>
-            <a:pPr algn="ctr"/>
-          </a:p>
-        </p:txBody>
-      </p:sp>
-      <p:sp>
-        <p:nvSpPr>
-          <p:cNvPr id="4" name="TextBox 3"/>
-          <p:cNvSpPr txBox="1"/>
-          <p:nvPr/>
-        </p:nvSpPr>
-        <p:spPr>
-          <a:xfrm>
-            <a:off x="502920" y="1737360"/>
-            <a:ext cx="822960" cy="777240"/>
-          </a:xfrm>
-          <a:prstGeom prst="rect">
-            <a:avLst/>
-          </a:prstGeom>
-          <a:noFill/>
-        </p:spPr>
-        <p:txBody>
-          <a:bodyPr wrap="none" lIns="0" rIns="0" tIns="0" bIns="0">
-            <a:spAutoFit/>
-          </a:bodyPr>
-          <a:lstStyle/>
-          <a:p>
-            <a:pPr algn="ctr"/>
-            <a:r>
-              <a:rPr sz="3200" b="1" i="0">
-                <a:solidFill>
-                  <a:srgbClr val="FFFFFF"/>
-                </a:solidFill>
-                <a:latin typeface="Helvetica Neue"/>
-                <a:ea typeface="Helvetica Neue"/>
-                <a:cs typeface="Helvetica Neue"/>
-              </a:rPr>
-              <a:t>1</a:t>
-            </a:r>
-          </a:p>
-        </p:txBody>
-      </p:sp>
-      <p:sp>
-        <p:nvSpPr>
-          <p:cNvPr id="5" name="TextBox 4"/>
-          <p:cNvSpPr txBox="1"/>
-          <p:nvPr/>
-        </p:nvSpPr>
-        <p:spPr>
-          <a:xfrm>
-            <a:off x="1554480" y="1901952"/>
-            <a:ext cx="10058400" cy="548640"/>
-          </a:xfrm>
-          <a:prstGeom prst="rect">
-            <a:avLst/>
-          </a:prstGeom>
-          <a:noFill/>
-        </p:spPr>
-        <p:txBody>
-          <a:bodyPr wrap="none" lIns="0" rIns="0" tIns="0" bIns="0">
-            <a:spAutoFit/>
-          </a:bodyPr>
-          <a:lstStyle/>
-          <a:p>
-            <a:r>
-              <a:rPr sz="1800" b="0" i="0">
-                <a:solidFill>
-                  <a:srgbClr val="1A1A1A"/>
-                </a:solidFill>
-                <a:latin typeface="Microsoft YaHei"/>
-                <a:ea typeface="Microsoft YaHei"/>
-                <a:cs typeface="Microsoft YaHei"/>
-              </a:rPr>
-              <a:t>5 分钟生成一份完整 deck</a:t>
-            </a:r>
-          </a:p>
-        </p:txBody>
-      </p:sp>
-      <p:sp>
-        <p:nvSpPr>
-          <p:cNvPr id="6" name="Rectangle 5"/>
-          <p:cNvSpPr/>
-          <p:nvPr/>
-        </p:nvSpPr>
-        <p:spPr>
-          <a:xfrm>
-            <a:off x="502920" y="2651760"/>
-            <a:ext cx="822960" cy="777240"/>
-          </a:xfrm>
-          <a:prstGeom prst="rect">
-            <a:avLst/>
-          </a:prstGeom>
-          <a:solidFill>
-            <a:srgbClr val="1E6FE0"/>
-          </a:solidFill>
-          <a:ln>
-            <a:noFill/>
-          </a:ln>
-        </p:spPr>
-        <p:style>
-          <a:lnRef idx="1">
-            <a:schemeClr val="accent1"/>
-          </a:lnRef>
-          <a:fillRef idx="3">
-            <a:schemeClr val="accent1"/>
-          </a:fillRef>
-          <a:effectRef idx="2">
-            <a:schemeClr val="accent1"/>
-          </a:effectRef>
-          <a:fontRef idx="minor">
-            <a:schemeClr val="lt1"/>
-          </a:fontRef>
-        </p:style>
-        <p:txBody>
-          <a:bodyPr rtlCol="0" anchor="ctr"/>
-          <a:lstStyle/>
-          <a:p>
-            <a:pPr algn="ctr"/>
-          </a:p>
-        </p:txBody>
-      </p:sp>
-      <p:sp>
-        <p:nvSpPr>
-          <p:cNvPr id="7" name="TextBox 6"/>
-          <p:cNvSpPr txBox="1"/>
-          <p:nvPr/>
-        </p:nvSpPr>
-        <p:spPr>
-          <a:xfrm>
-            <a:off x="502920" y="2651760"/>
-            <a:ext cx="822960" cy="777240"/>
-          </a:xfrm>
-          <a:prstGeom prst="rect">
-            <a:avLst/>
-          </a:prstGeom>
-          <a:noFill/>
-        </p:spPr>
-        <p:txBody>
-          <a:bodyPr wrap="none" lIns="0" rIns="0" tIns="0" bIns="0">
-            <a:spAutoFit/>
-          </a:bodyPr>
-          <a:lstStyle/>
-          <a:p>
-            <a:pPr algn="ctr"/>
-            <a:r>
-              <a:rPr sz="3200" b="1" i="0">
-                <a:solidFill>
-                  <a:srgbClr val="FFFFFF"/>
-                </a:solidFill>
-                <a:latin typeface="Helvetica Neue"/>
-                <a:ea typeface="Helvetica Neue"/>
-                <a:cs typeface="Helvetica Neue"/>
-              </a:rPr>
-              <a:t>2</a:t>
-            </a:r>
-          </a:p>
-        </p:txBody>
-      </p:sp>
-      <p:sp>
-        <p:nvSpPr>
-          <p:cNvPr id="8" name="TextBox 7"/>
-          <p:cNvSpPr txBox="1"/>
-          <p:nvPr/>
-        </p:nvSpPr>
-        <p:spPr>
-          <a:xfrm>
-            <a:off x="1554480" y="2816352"/>
-            <a:ext cx="10058400" cy="548640"/>
-          </a:xfrm>
-          <a:prstGeom prst="rect">
-            <a:avLst/>
-          </a:prstGeom>
-          <a:noFill/>
-        </p:spPr>
-        <p:txBody>
-          <a:bodyPr wrap="none" lIns="0" rIns="0" tIns="0" bIns="0">
-            <a:spAutoFit/>
-          </a:bodyPr>
-          <a:lstStyle/>
-          <a:p>
-            <a:r>
-              <a:rPr sz="1800" b="0" i="0">
-                <a:solidFill>
-                  <a:srgbClr val="1A1A1A"/>
-                </a:solidFill>
-                <a:latin typeface="Microsoft YaHei"/>
-                <a:ea typeface="Microsoft YaHei"/>
-                <a:cs typeface="Microsoft YaHei"/>
-              </a:rPr>
-              <a:t>视觉自检 + 自动修复</a:t>
-            </a:r>
-          </a:p>
-        </p:txBody>
-      </p:sp>
-      <p:sp>
-        <p:nvSpPr>
-          <p:cNvPr id="9" name="Rectangle 8"/>
-          <p:cNvSpPr/>
-          <p:nvPr/>
-        </p:nvSpPr>
-        <p:spPr>
-          <a:xfrm>
-            <a:off x="502920" y="3566160"/>
-            <a:ext cx="822960" cy="777240"/>
-          </a:xfrm>
-          <a:prstGeom prst="rect">
-            <a:avLst/>
-          </a:prstGeom>
-          <a:solidFill>
-            <a:srgbClr val="1E6FE0"/>
-          </a:solidFill>
-          <a:ln>
-            <a:noFill/>
-          </a:ln>
-        </p:spPr>
-        <p:style>
-          <a:lnRef idx="1">
-            <a:schemeClr val="accent1"/>
-          </a:lnRef>
-          <a:fillRef idx="3">
-            <a:schemeClr val="accent1"/>
-          </a:fillRef>
-          <a:effectRef idx="2">
-            <a:schemeClr val="accent1"/>
-          </a:effectRef>
-          <a:fontRef idx="minor">
-            <a:schemeClr val="lt1"/>
-          </a:fontRef>
-        </p:style>
-        <p:txBody>
-          <a:bodyPr rtlCol="0" anchor="ctr"/>
-          <a:lstStyle/>
-          <a:p>
-            <a:pPr algn="ctr"/>
-          </a:p>
-        </p:txBody>
-      </p:sp>
-      <p:sp>
-        <p:nvSpPr>
-          <p:cNvPr id="10" name="TextBox 9"/>
-          <p:cNvSpPr txBox="1"/>
-          <p:nvPr/>
-        </p:nvSpPr>
-        <p:spPr>
-          <a:xfrm>
-            <a:off x="502920" y="3566160"/>
-            <a:ext cx="822960" cy="777240"/>
-          </a:xfrm>
-          <a:prstGeom prst="rect">
-            <a:avLst/>
-          </a:prstGeom>
-          <a:noFill/>
-        </p:spPr>
-        <p:txBody>
-          <a:bodyPr wrap="none" lIns="0" rIns="0" tIns="0" bIns="0">
-            <a:spAutoFit/>
-          </a:bodyPr>
-          <a:lstStyle/>
-          <a:p>
-            <a:pPr algn="ctr"/>
-            <a:r>
-              <a:rPr sz="3200" b="1" i="0">
-                <a:solidFill>
-                  <a:srgbClr val="FFFFFF"/>
-                </a:solidFill>
-                <a:latin typeface="Helvetica Neue"/>
-                <a:ea typeface="Helvetica Neue"/>
-                <a:cs typeface="Helvetica Neue"/>
-              </a:rPr>
-              <a:t>3</a:t>
-            </a:r>
-          </a:p>
-        </p:txBody>
-      </p:sp>
-      <p:sp>
-        <p:nvSpPr>
-          <p:cNvPr id="11" name="TextBox 10"/>
-          <p:cNvSpPr txBox="1"/>
-          <p:nvPr/>
-        </p:nvSpPr>
-        <p:spPr>
-          <a:xfrm>
-            <a:off x="1554480" y="3730752"/>
-            <a:ext cx="10058400" cy="548640"/>
-          </a:xfrm>
-          <a:prstGeom prst="rect">
-            <a:avLst/>
-          </a:prstGeom>
-          <a:noFill/>
-        </p:spPr>
-        <p:txBody>
-          <a:bodyPr wrap="none" lIns="0" rIns="0" tIns="0" bIns="0">
-            <a:spAutoFit/>
-          </a:bodyPr>
-          <a:lstStyle/>
-          <a:p>
-            <a:r>
-              <a:rPr sz="1800" b="0" i="0">
-                <a:solidFill>
-                  <a:srgbClr val="1A1A1A"/>
-                </a:solidFill>
-                <a:latin typeface="Microsoft YaHei"/>
-                <a:ea typeface="Microsoft YaHei"/>
-                <a:cs typeface="Microsoft YaHei"/>
-              </a:rPr>
-              <a:t>支持模板学风格</a:t>
-            </a:r>
-          </a:p>
-        </p:txBody>
-      </p:sp>
-    </p:spTree>
-  </p:cSld>
-  <p:clrMapOvr>
-    <a:masterClrMapping/>
-  </p:clrMapOvr>
-</p:sld>
-</file>
-
-<file path=ppt/slides/slide12.xml><?xml version="1.0" encoding="utf-8"?>
-<p:sld xmlns:a="http://schemas.openxmlformats.org/drawingml/2006/main" xmlns:p="http://schemas.openxmlformats.org/presentationml/2006/main" xmlns:r="http://schemas.openxmlformats.org/officeDocument/2006/relationships">
-  <p:cSld>
-    <p:spTree>
-      <p:nvGrpSpPr>
-        <p:cNvPr id="1" name=""/>
-        <p:cNvGrpSpPr/>
-        <p:nvPr/>
-      </p:nvGrpSpPr>
-      <p:grpSpPr/>
-      <p:sp>
-        <p:nvSpPr>
-          <p:cNvPr id="2" name="Rectangle 1"/>
-          <p:cNvSpPr/>
-          <p:nvPr/>
-        </p:nvSpPr>
-        <p:spPr>
-          <a:xfrm>
-            <a:off x="0" y="0"/>
-            <a:ext cx="12191695" cy="6858000"/>
-          </a:xfrm>
-          <a:prstGeom prst="rect">
-            <a:avLst/>
-          </a:prstGeom>
-          <a:solidFill>
-            <a:srgbClr val="0B2A4A"/>
-          </a:solidFill>
-          <a:ln>
-            <a:noFill/>
-          </a:ln>
-        </p:spPr>
-        <p:style>
-          <a:lnRef idx="1">
-            <a:schemeClr val="accent1"/>
-          </a:lnRef>
-          <a:fillRef idx="3">
-            <a:schemeClr val="accent1"/>
-          </a:fillRef>
-          <a:effectRef idx="2">
-            <a:schemeClr val="accent1"/>
-          </a:effectRef>
-          <a:fontRef idx="minor">
-            <a:schemeClr val="lt1"/>
-          </a:fontRef>
-        </p:style>
-        <p:txBody>
-          <a:bodyPr rtlCol="0" anchor="ctr"/>
-          <a:lstStyle/>
-          <a:p>
-            <a:pPr algn="ctr"/>
-          </a:p>
-        </p:txBody>
-      </p:sp>
-      <p:sp>
-        <p:nvSpPr>
-          <p:cNvPr id="3" name="TextBox 2"/>
-          <p:cNvSpPr txBox="1"/>
-          <p:nvPr/>
-        </p:nvSpPr>
-        <p:spPr>
-          <a:xfrm>
-            <a:off x="502920" y="2743200"/>
-            <a:ext cx="10972800" cy="1371600"/>
-          </a:xfrm>
-          <a:prstGeom prst="rect">
-            <a:avLst/>
-          </a:prstGeom>
-          <a:noFill/>
-        </p:spPr>
-        <p:txBody>
-          <a:bodyPr wrap="none" lIns="0" rIns="0" tIns="0" bIns="0">
-            <a:spAutoFit/>
-          </a:bodyPr>
-          <a:lstStyle/>
-          <a:p>
-            <a:pPr algn="ctr"/>
-            <a:r>
-              <a:rPr sz="6400" b="1" i="0">
-                <a:solidFill>
-                  <a:srgbClr val="FFFFFF"/>
-                </a:solidFill>
-                <a:latin typeface="Microsoft YaHei"/>
-                <a:ea typeface="Microsoft YaHei"/>
-                <a:cs typeface="Microsoft YaHei"/>
-              </a:rPr>
-              <a:t>谢谢</a:t>
-            </a:r>
-          </a:p>
-        </p:txBody>
-      </p:sp>
-      <p:sp>
-        <p:nvSpPr>
-          <p:cNvPr id="4" name="TextBox 3"/>
-          <p:cNvSpPr txBox="1"/>
-          <p:nvPr/>
-        </p:nvSpPr>
-        <p:spPr>
-          <a:xfrm>
-            <a:off x="502920" y="4206240"/>
-            <a:ext cx="10972800" cy="548640"/>
-          </a:xfrm>
-          <a:prstGeom prst="rect">
-            <a:avLst/>
-          </a:prstGeom>
-          <a:noFill/>
-        </p:spPr>
-        <p:txBody>
-          <a:bodyPr wrap="none" lIns="0" rIns="0" tIns="0" bIns="0">
-            <a:spAutoFit/>
-          </a:bodyPr>
-          <a:lstStyle/>
-          <a:p>
-            <a:pPr algn="ctr"/>
-            <a:r>
-              <a:rPr sz="1600" b="0" i="0">
-                <a:solidFill>
-                  <a:srgbClr val="E6F0FC"/>
-                </a:solidFill>
-                <a:latin typeface="Microsoft YaHei"/>
-                <a:ea typeface="Microsoft YaHei"/>
-                <a:cs typeface="Microsoft YaHei"/>
-              </a:rPr>
-              <a:t/>
+              <a:t>deck_plan 驱动的机械构建</a:t>
             </a:r>
           </a:p>
         </p:txBody>
@@ -3977,8 +3274,8 @@
         </p:nvSpPr>
         <p:spPr>
           <a:xfrm>
-            <a:off x="1371600" y="1645920"/>
-            <a:ext cx="640080" cy="548640"/>
+            <a:off x="502920" y="1280160"/>
+            <a:ext cx="640080" cy="1584960"/>
           </a:xfrm>
           <a:prstGeom prst="rect">
             <a:avLst/>
@@ -4013,8 +3310,8 @@
         </p:nvSpPr>
         <p:spPr>
           <a:xfrm>
-            <a:off x="2194560" y="1645920"/>
-            <a:ext cx="9144000" cy="548640"/>
+            <a:off x="1325880" y="1280160"/>
+            <a:ext cx="10362895" cy="1584960"/>
           </a:xfrm>
           <a:prstGeom prst="rect">
             <a:avLst/>
@@ -4036,7 +3333,7 @@
                 <a:ea typeface="Microsoft YaHei"/>
                 <a:cs typeface="Microsoft YaHei"/>
               </a:rPr>
-              <a:t>动机</a:t>
+              <a:t>背景</a:t>
             </a:r>
           </a:p>
         </p:txBody>
@@ -4049,8 +3346,8 @@
         </p:nvSpPr>
         <p:spPr>
           <a:xfrm>
-            <a:off x="1371600" y="2286000"/>
-            <a:ext cx="640080" cy="548640"/>
+            <a:off x="502920" y="3048000"/>
+            <a:ext cx="640080" cy="1584960"/>
           </a:xfrm>
           <a:prstGeom prst="rect">
             <a:avLst/>
@@ -4085,8 +3382,8 @@
         </p:nvSpPr>
         <p:spPr>
           <a:xfrm>
-            <a:off x="2194560" y="2286000"/>
-            <a:ext cx="9144000" cy="548640"/>
+            <a:off x="1325880" y="3048000"/>
+            <a:ext cx="10362895" cy="1584960"/>
           </a:xfrm>
           <a:prstGeom prst="rect">
             <a:avLst/>
@@ -4108,7 +3405,7 @@
                 <a:ea typeface="Microsoft YaHei"/>
                 <a:cs typeface="Microsoft YaHei"/>
               </a:rPr>
-              <a:t>技术方案</a:t>
+              <a:t>方案</a:t>
             </a:r>
           </a:p>
         </p:txBody>
@@ -4121,8 +3418,8 @@
         </p:nvSpPr>
         <p:spPr>
           <a:xfrm>
-            <a:off x="1371600" y="2926080"/>
-            <a:ext cx="640080" cy="548640"/>
+            <a:off x="502920" y="4815840"/>
+            <a:ext cx="640080" cy="1584960"/>
           </a:xfrm>
           <a:prstGeom prst="rect">
             <a:avLst/>
@@ -4157,8 +3454,8 @@
         </p:nvSpPr>
         <p:spPr>
           <a:xfrm>
-            <a:off x="2194560" y="2926080"/>
-            <a:ext cx="9144000" cy="548640"/>
+            <a:off x="1325880" y="4815840"/>
+            <a:ext cx="10362895" cy="1584960"/>
           </a:xfrm>
           <a:prstGeom prst="rect">
             <a:avLst/>
@@ -4180,79 +3477,7 @@
                 <a:ea typeface="Microsoft YaHei"/>
                 <a:cs typeface="Microsoft YaHei"/>
               </a:rPr>
-              <a:t>效果数据</a:t>
-            </a:r>
-          </a:p>
-        </p:txBody>
-      </p:sp>
-      <p:sp>
-        <p:nvSpPr>
-          <p:cNvPr id="9" name="TextBox 8"/>
-          <p:cNvSpPr txBox="1"/>
-          <p:nvPr/>
-        </p:nvSpPr>
-        <p:spPr>
-          <a:xfrm>
-            <a:off x="1371600" y="3566159"/>
-            <a:ext cx="640080" cy="548640"/>
-          </a:xfrm>
-          <a:prstGeom prst="rect">
-            <a:avLst/>
-          </a:prstGeom>
-          <a:noFill/>
-        </p:spPr>
-        <p:txBody>
-          <a:bodyPr wrap="none" lIns="0" rIns="0" tIns="0" bIns="0">
-            <a:spAutoFit/>
-          </a:bodyPr>
-          <a:lstStyle/>
-          <a:p>
-            <a:r>
-              <a:rPr sz="2600" b="1" i="0">
-                <a:solidFill>
-                  <a:srgbClr val="1E6FE0"/>
-                </a:solidFill>
-                <a:latin typeface="Helvetica Neue"/>
-                <a:ea typeface="Helvetica Neue"/>
-                <a:cs typeface="Helvetica Neue"/>
-              </a:rPr>
-              <a:t>04</a:t>
-            </a:r>
-          </a:p>
-        </p:txBody>
-      </p:sp>
-      <p:sp>
-        <p:nvSpPr>
-          <p:cNvPr id="10" name="TextBox 9"/>
-          <p:cNvSpPr txBox="1"/>
-          <p:nvPr/>
-        </p:nvSpPr>
-        <p:spPr>
-          <a:xfrm>
-            <a:off x="2194560" y="3566159"/>
-            <a:ext cx="9144000" cy="548640"/>
-          </a:xfrm>
-          <a:prstGeom prst="rect">
-            <a:avLst/>
-          </a:prstGeom>
-          <a:noFill/>
-        </p:spPr>
-        <p:txBody>
-          <a:bodyPr wrap="none" lIns="0" rIns="0" tIns="0" bIns="0">
-            <a:spAutoFit/>
-          </a:bodyPr>
-          <a:lstStyle/>
-          <a:p>
-            <a:r>
-              <a:rPr sz="2000" b="0" i="0">
-                <a:solidFill>
-                  <a:srgbClr val="1A1A1A"/>
-                </a:solidFill>
-                <a:latin typeface="Microsoft YaHei"/>
-                <a:ea typeface="Microsoft YaHei"/>
-                <a:cs typeface="Microsoft YaHei"/>
-              </a:rPr>
-              <a:t>落地路径</a:t>
+              <a:t>效果</a:t>
             </a:r>
           </a:p>
         </p:txBody>
@@ -4386,7 +3611,7 @@
                 <a:ea typeface="Microsoft YaHei"/>
                 <a:cs typeface="Microsoft YaHei"/>
               </a:rPr>
-              <a:t>动机</a:t>
+              <a:t>背景</a:t>
             </a:r>
           </a:p>
         </p:txBody>
@@ -4440,7 +3665,7 @@
                 <a:ea typeface="Microsoft YaHei"/>
                 <a:cs typeface="Microsoft YaHei"/>
               </a:rPr>
-              <a:t>动机</a:t>
+              <a:t>三个痛点</a:t>
             </a:r>
           </a:p>
         </p:txBody>
@@ -4453,8 +3678,8 @@
         </p:nvSpPr>
         <p:spPr>
           <a:xfrm>
-            <a:off x="502920" y="1645920"/>
-            <a:ext cx="11155680" cy="4754880"/>
+            <a:off x="502920" y="3398520"/>
+            <a:ext cx="11185855" cy="883920"/>
           </a:xfrm>
           <a:prstGeom prst="rect">
             <a:avLst/>
@@ -4492,7 +3717,7 @@
                 <a:ea typeface="Microsoft YaHei"/>
                 <a:cs typeface="Microsoft YaHei"/>
               </a:rPr>
-              <a:t>5 分钟生成一份完整 deck</a:t>
+              <a:t>文字墙</a:t>
             </a:r>
           </a:p>
           <a:p>
@@ -4521,7 +3746,7 @@
                 <a:ea typeface="Microsoft YaHei"/>
                 <a:cs typeface="Microsoft YaHei"/>
               </a:rPr>
-              <a:t>视觉自检 + 自动修复</a:t>
+              <a:t>留白多</a:t>
             </a:r>
           </a:p>
           <a:p>
@@ -4550,7 +3775,7 @@
                 <a:ea typeface="Microsoft YaHei"/>
                 <a:cs typeface="Microsoft YaHei"/>
               </a:rPr>
-              <a:t>支持模板学风格</a:t>
+              <a:t>改动散</a:t>
             </a:r>
           </a:p>
         </p:txBody>
@@ -4575,23 +3800,63 @@
       <p:grpSpPr/>
       <p:sp>
         <p:nvSpPr>
-          <p:cNvPr id="2" name="Rectangle 1"/>
-          <p:cNvSpPr/>
+          <p:cNvPr id="2" name="TextBox 1"/>
+          <p:cNvSpPr txBox="1"/>
           <p:nvPr/>
         </p:nvSpPr>
         <p:spPr>
           <a:xfrm>
-            <a:off x="502920" y="1737360"/>
-            <a:ext cx="1554480" cy="1828800"/>
+            <a:off x="502920" y="548640"/>
+            <a:ext cx="11155680" cy="731520"/>
           </a:xfrm>
           <a:prstGeom prst="rect">
             <a:avLst/>
           </a:prstGeom>
+          <a:noFill/>
+        </p:spPr>
+        <p:txBody>
+          <a:bodyPr wrap="none" lIns="0" rIns="0" tIns="0" bIns="0">
+            <a:spAutoFit/>
+          </a:bodyPr>
+          <a:lstStyle/>
+          <a:p>
+            <a:r>
+              <a:rPr sz="2800" b="1" i="0">
+                <a:solidFill>
+                  <a:srgbClr val="0B2A4A"/>
+                </a:solidFill>
+                <a:latin typeface="Microsoft YaHei"/>
+                <a:ea typeface="Microsoft YaHei"/>
+                <a:cs typeface="Microsoft YaHei"/>
+              </a:rPr>
+              <a:t>三大改进</a:t>
+            </a:r>
+          </a:p>
+        </p:txBody>
+      </p:sp>
+      <p:sp>
+        <p:nvSpPr>
+          <p:cNvPr id="3" name="Rounded Rectangle 2"/>
+          <p:cNvSpPr/>
+          <p:nvPr/>
+        </p:nvSpPr>
+        <p:spPr>
+          <a:xfrm>
+            <a:off x="502920" y="1280160"/>
+            <a:ext cx="3545738" cy="5120640"/>
+          </a:xfrm>
+          <a:prstGeom prst="roundRect">
+            <a:avLst>
+              <a:gd name="adj" fmla="val 5000"/>
+            </a:avLst>
+          </a:prstGeom>
           <a:solidFill>
-            <a:srgbClr val="0B2A4A"/>
+            <a:srgbClr val="FFFFFF"/>
           </a:solidFill>
-          <a:ln>
-            <a:noFill/>
+          <a:ln w="9525">
+            <a:solidFill>
+              <a:srgbClr val="D9D9D9"/>
+            </a:solidFill>
           </a:ln>
         </p:spPr>
         <p:style>
@@ -4618,14 +3883,59 @@
       </p:sp>
       <p:sp>
         <p:nvSpPr>
-          <p:cNvPr id="3" name="TextBox 2"/>
+          <p:cNvPr id="4" name="Rounded Rectangle 3"/>
+          <p:cNvSpPr/>
+          <p:nvPr/>
+        </p:nvSpPr>
+        <p:spPr>
+          <a:xfrm>
+            <a:off x="502920" y="1280160"/>
+            <a:ext cx="36576" cy="5120640"/>
+          </a:xfrm>
+          <a:prstGeom prst="roundRect">
+            <a:avLst>
+              <a:gd name="adj" fmla="val 5000"/>
+            </a:avLst>
+          </a:prstGeom>
+          <a:solidFill>
+            <a:srgbClr val="1E6FE0"/>
+          </a:solidFill>
+          <a:ln>
+            <a:noFill/>
+          </a:ln>
+        </p:spPr>
+        <p:style>
+          <a:lnRef idx="1">
+            <a:schemeClr val="accent1"/>
+          </a:lnRef>
+          <a:fillRef idx="3">
+            <a:schemeClr val="accent1"/>
+          </a:fillRef>
+          <a:effectRef idx="2">
+            <a:schemeClr val="accent1"/>
+          </a:effectRef>
+          <a:fontRef idx="minor">
+            <a:schemeClr val="lt1"/>
+          </a:fontRef>
+        </p:style>
+        <p:txBody>
+          <a:bodyPr rtlCol="0" anchor="ctr"/>
+          <a:lstStyle/>
+          <a:p>
+            <a:pPr algn="ctr"/>
+          </a:p>
+        </p:txBody>
+      </p:sp>
+      <p:sp>
+        <p:nvSpPr>
+          <p:cNvPr id="5" name="TextBox 4"/>
           <p:cNvSpPr txBox="1"/>
           <p:nvPr/>
         </p:nvSpPr>
         <p:spPr>
           <a:xfrm>
-            <a:off x="502920" y="1737360"/>
-            <a:ext cx="1554480" cy="1828800"/>
+            <a:off x="777240" y="1508760"/>
+            <a:ext cx="2997098" cy="457200"/>
           </a:xfrm>
           <a:prstGeom prst="rect">
             <a:avLst/>
@@ -4633,36 +3943,36 @@
           <a:noFill/>
         </p:spPr>
         <p:txBody>
-          <a:bodyPr wrap="none" lIns="0" rIns="0" tIns="0" bIns="0">
+          <a:bodyPr wrap="square" lIns="0" rIns="0" tIns="0" bIns="0">
             <a:spAutoFit/>
           </a:bodyPr>
           <a:lstStyle/>
           <a:p>
-            <a:pPr algn="ctr"/>
-            <a:r>
-              <a:rPr sz="8000" b="1" i="0">
-                <a:solidFill>
-                  <a:srgbClr val="FFFFFF"/>
-                </a:solidFill>
-                <a:latin typeface="Helvetica Neue"/>
-                <a:ea typeface="Helvetica Neue"/>
-                <a:cs typeface="Helvetica Neue"/>
+            <a:pPr algn="l"/>
+            <a:r>
+              <a:rPr sz="1800" b="1" i="0">
+                <a:solidFill>
+                  <a:srgbClr val="0B2A4A"/>
+                </a:solidFill>
+                <a:latin typeface="Microsoft YaHei"/>
+                <a:ea typeface="Microsoft YaHei"/>
+                <a:cs typeface="Microsoft YaHei"/>
               </a:rPr>
-              <a:t>2</a:t>
-            </a:r>
-          </a:p>
-        </p:txBody>
-      </p:sp>
-      <p:sp>
-        <p:nvSpPr>
-          <p:cNvPr id="4" name="TextBox 3"/>
+              <a:t>接缝</a:t>
+            </a:r>
+          </a:p>
+        </p:txBody>
+      </p:sp>
+      <p:sp>
+        <p:nvSpPr>
+          <p:cNvPr id="6" name="TextBox 5"/>
           <p:cNvSpPr txBox="1"/>
           <p:nvPr/>
         </p:nvSpPr>
         <p:spPr>
           <a:xfrm>
-            <a:off x="2331720" y="2103120"/>
-            <a:ext cx="9144000" cy="1097280"/>
+            <a:off x="777240" y="2103120"/>
+            <a:ext cx="2997098" cy="1828800"/>
           </a:xfrm>
           <a:prstGeom prst="rect">
             <a:avLst/>
@@ -4670,21 +3980,354 @@
           <a:noFill/>
         </p:spPr>
         <p:txBody>
-          <a:bodyPr wrap="none" lIns="0" rIns="0" tIns="0" bIns="0">
+          <a:bodyPr wrap="square" lIns="0" rIns="0" tIns="0" bIns="0">
             <a:spAutoFit/>
           </a:bodyPr>
           <a:lstStyle/>
           <a:p>
-            <a:r>
-              <a:rPr sz="3600" b="1" i="0">
-                <a:solidFill>
-                  <a:srgbClr val="0B2A4A"/>
+            <a:pPr algn="l"/>
+            <a:r>
+              <a:rPr sz="1300" b="0" i="0">
+                <a:solidFill>
+                  <a:srgbClr val="1A1A1A"/>
                 </a:solidFill>
                 <a:latin typeface="Microsoft YaHei"/>
                 <a:ea typeface="Microsoft YaHei"/>
                 <a:cs typeface="Microsoft YaHei"/>
               </a:rPr>
-              <a:t>技术方案</a:t>
+              <a:t>deck_plan.json 隔开机械与智能</a:t>
+            </a:r>
+          </a:p>
+        </p:txBody>
+      </p:sp>
+      <p:sp>
+        <p:nvSpPr>
+          <p:cNvPr id="7" name="Rounded Rectangle 6"/>
+          <p:cNvSpPr/>
+          <p:nvPr/>
+        </p:nvSpPr>
+        <p:spPr>
+          <a:xfrm>
+            <a:off x="4322978" y="1280160"/>
+            <a:ext cx="3545738" cy="5120640"/>
+          </a:xfrm>
+          <a:prstGeom prst="roundRect">
+            <a:avLst>
+              <a:gd name="adj" fmla="val 5000"/>
+            </a:avLst>
+          </a:prstGeom>
+          <a:solidFill>
+            <a:srgbClr val="FFFFFF"/>
+          </a:solidFill>
+          <a:ln w="9525">
+            <a:solidFill>
+              <a:srgbClr val="D9D9D9"/>
+            </a:solidFill>
+          </a:ln>
+        </p:spPr>
+        <p:style>
+          <a:lnRef idx="1">
+            <a:schemeClr val="accent1"/>
+          </a:lnRef>
+          <a:fillRef idx="3">
+            <a:schemeClr val="accent1"/>
+          </a:fillRef>
+          <a:effectRef idx="2">
+            <a:schemeClr val="accent1"/>
+          </a:effectRef>
+          <a:fontRef idx="minor">
+            <a:schemeClr val="lt1"/>
+          </a:fontRef>
+        </p:style>
+        <p:txBody>
+          <a:bodyPr rtlCol="0" anchor="ctr"/>
+          <a:lstStyle/>
+          <a:p>
+            <a:pPr algn="ctr"/>
+          </a:p>
+        </p:txBody>
+      </p:sp>
+      <p:sp>
+        <p:nvSpPr>
+          <p:cNvPr id="8" name="Rounded Rectangle 7"/>
+          <p:cNvSpPr/>
+          <p:nvPr/>
+        </p:nvSpPr>
+        <p:spPr>
+          <a:xfrm>
+            <a:off x="4322978" y="1280160"/>
+            <a:ext cx="36576" cy="5120640"/>
+          </a:xfrm>
+          <a:prstGeom prst="roundRect">
+            <a:avLst>
+              <a:gd name="adj" fmla="val 5000"/>
+            </a:avLst>
+          </a:prstGeom>
+          <a:solidFill>
+            <a:srgbClr val="1E6FE0"/>
+          </a:solidFill>
+          <a:ln>
+            <a:noFill/>
+          </a:ln>
+        </p:spPr>
+        <p:style>
+          <a:lnRef idx="1">
+            <a:schemeClr val="accent1"/>
+          </a:lnRef>
+          <a:fillRef idx="3">
+            <a:schemeClr val="accent1"/>
+          </a:fillRef>
+          <a:effectRef idx="2">
+            <a:schemeClr val="accent1"/>
+          </a:effectRef>
+          <a:fontRef idx="minor">
+            <a:schemeClr val="lt1"/>
+          </a:fontRef>
+        </p:style>
+        <p:txBody>
+          <a:bodyPr rtlCol="0" anchor="ctr"/>
+          <a:lstStyle/>
+          <a:p>
+            <a:pPr algn="ctr"/>
+          </a:p>
+        </p:txBody>
+      </p:sp>
+      <p:sp>
+        <p:nvSpPr>
+          <p:cNvPr id="9" name="TextBox 8"/>
+          <p:cNvSpPr txBox="1"/>
+          <p:nvPr/>
+        </p:nvSpPr>
+        <p:spPr>
+          <a:xfrm>
+            <a:off x="4597298" y="1508760"/>
+            <a:ext cx="2997098" cy="457200"/>
+          </a:xfrm>
+          <a:prstGeom prst="rect">
+            <a:avLst/>
+          </a:prstGeom>
+          <a:noFill/>
+        </p:spPr>
+        <p:txBody>
+          <a:bodyPr wrap="square" lIns="0" rIns="0" tIns="0" bIns="0">
+            <a:spAutoFit/>
+          </a:bodyPr>
+          <a:lstStyle/>
+          <a:p>
+            <a:pPr algn="l"/>
+            <a:r>
+              <a:rPr sz="1800" b="1" i="0">
+                <a:solidFill>
+                  <a:srgbClr val="0B2A4A"/>
+                </a:solidFill>
+                <a:latin typeface="Microsoft YaHei"/>
+                <a:ea typeface="Microsoft YaHei"/>
+                <a:cs typeface="Microsoft YaHei"/>
+              </a:rPr>
+              <a:t>原语</a:t>
+            </a:r>
+          </a:p>
+        </p:txBody>
+      </p:sp>
+      <p:sp>
+        <p:nvSpPr>
+          <p:cNvPr id="10" name="TextBox 9"/>
+          <p:cNvSpPr txBox="1"/>
+          <p:nvPr/>
+        </p:nvSpPr>
+        <p:spPr>
+          <a:xfrm>
+            <a:off x="4597298" y="2103120"/>
+            <a:ext cx="2997098" cy="1828800"/>
+          </a:xfrm>
+          <a:prstGeom prst="rect">
+            <a:avLst/>
+          </a:prstGeom>
+          <a:noFill/>
+        </p:spPr>
+        <p:txBody>
+          <a:bodyPr wrap="square" lIns="0" rIns="0" tIns="0" bIns="0">
+            <a:spAutoFit/>
+          </a:bodyPr>
+          <a:lstStyle/>
+          <a:p>
+            <a:pPr algn="l"/>
+            <a:r>
+              <a:rPr sz="1300" b="0" i="0">
+                <a:solidFill>
+                  <a:srgbClr val="1A1A1A"/>
+                </a:solidFill>
+                <a:latin typeface="Microsoft YaHei"/>
+                <a:ea typeface="Microsoft YaHei"/>
+                <a:cs typeface="Microsoft YaHei"/>
+              </a:rPr>
+              <a:t>layout.py 几何原语,数量灵活</a:t>
+            </a:r>
+          </a:p>
+        </p:txBody>
+      </p:sp>
+      <p:sp>
+        <p:nvSpPr>
+          <p:cNvPr id="11" name="Rounded Rectangle 10"/>
+          <p:cNvSpPr/>
+          <p:nvPr/>
+        </p:nvSpPr>
+        <p:spPr>
+          <a:xfrm>
+            <a:off x="8143036" y="1280160"/>
+            <a:ext cx="3545738" cy="5120640"/>
+          </a:xfrm>
+          <a:prstGeom prst="roundRect">
+            <a:avLst>
+              <a:gd name="adj" fmla="val 5000"/>
+            </a:avLst>
+          </a:prstGeom>
+          <a:solidFill>
+            <a:srgbClr val="FFFFFF"/>
+          </a:solidFill>
+          <a:ln w="9525">
+            <a:solidFill>
+              <a:srgbClr val="D9D9D9"/>
+            </a:solidFill>
+          </a:ln>
+        </p:spPr>
+        <p:style>
+          <a:lnRef idx="1">
+            <a:schemeClr val="accent1"/>
+          </a:lnRef>
+          <a:fillRef idx="3">
+            <a:schemeClr val="accent1"/>
+          </a:fillRef>
+          <a:effectRef idx="2">
+            <a:schemeClr val="accent1"/>
+          </a:effectRef>
+          <a:fontRef idx="minor">
+            <a:schemeClr val="lt1"/>
+          </a:fontRef>
+        </p:style>
+        <p:txBody>
+          <a:bodyPr rtlCol="0" anchor="ctr"/>
+          <a:lstStyle/>
+          <a:p>
+            <a:pPr algn="ctr"/>
+          </a:p>
+        </p:txBody>
+      </p:sp>
+      <p:sp>
+        <p:nvSpPr>
+          <p:cNvPr id="12" name="Rounded Rectangle 11"/>
+          <p:cNvSpPr/>
+          <p:nvPr/>
+        </p:nvSpPr>
+        <p:spPr>
+          <a:xfrm>
+            <a:off x="8143036" y="1280160"/>
+            <a:ext cx="36576" cy="5120640"/>
+          </a:xfrm>
+          <a:prstGeom prst="roundRect">
+            <a:avLst>
+              <a:gd name="adj" fmla="val 5000"/>
+            </a:avLst>
+          </a:prstGeom>
+          <a:solidFill>
+            <a:srgbClr val="1E6FE0"/>
+          </a:solidFill>
+          <a:ln>
+            <a:noFill/>
+          </a:ln>
+        </p:spPr>
+        <p:style>
+          <a:lnRef idx="1">
+            <a:schemeClr val="accent1"/>
+          </a:lnRef>
+          <a:fillRef idx="3">
+            <a:schemeClr val="accent1"/>
+          </a:fillRef>
+          <a:effectRef idx="2">
+            <a:schemeClr val="accent1"/>
+          </a:effectRef>
+          <a:fontRef idx="minor">
+            <a:schemeClr val="lt1"/>
+          </a:fontRef>
+        </p:style>
+        <p:txBody>
+          <a:bodyPr rtlCol="0" anchor="ctr"/>
+          <a:lstStyle/>
+          <a:p>
+            <a:pPr algn="ctr"/>
+          </a:p>
+        </p:txBody>
+      </p:sp>
+      <p:sp>
+        <p:nvSpPr>
+          <p:cNvPr id="13" name="TextBox 12"/>
+          <p:cNvSpPr txBox="1"/>
+          <p:nvPr/>
+        </p:nvSpPr>
+        <p:spPr>
+          <a:xfrm>
+            <a:off x="8417356" y="1508760"/>
+            <a:ext cx="2997098" cy="457200"/>
+          </a:xfrm>
+          <a:prstGeom prst="rect">
+            <a:avLst/>
+          </a:prstGeom>
+          <a:noFill/>
+        </p:spPr>
+        <p:txBody>
+          <a:bodyPr wrap="square" lIns="0" rIns="0" tIns="0" bIns="0">
+            <a:spAutoFit/>
+          </a:bodyPr>
+          <a:lstStyle/>
+          <a:p>
+            <a:pPr algn="l"/>
+            <a:r>
+              <a:rPr sz="1800" b="1" i="0">
+                <a:solidFill>
+                  <a:srgbClr val="0B2A4A"/>
+                </a:solidFill>
+                <a:latin typeface="Microsoft YaHei"/>
+                <a:ea typeface="Microsoft YaHei"/>
+                <a:cs typeface="Microsoft YaHei"/>
+              </a:rPr>
+              <a:t>回归</a:t>
+            </a:r>
+          </a:p>
+        </p:txBody>
+      </p:sp>
+      <p:sp>
+        <p:nvSpPr>
+          <p:cNvPr id="14" name="TextBox 13"/>
+          <p:cNvSpPr txBox="1"/>
+          <p:nvPr/>
+        </p:nvSpPr>
+        <p:spPr>
+          <a:xfrm>
+            <a:off x="8417356" y="2103120"/>
+            <a:ext cx="2997098" cy="1828800"/>
+          </a:xfrm>
+          <a:prstGeom prst="rect">
+            <a:avLst/>
+          </a:prstGeom>
+          <a:noFill/>
+        </p:spPr>
+        <p:txBody>
+          <a:bodyPr wrap="square" lIns="0" rIns="0" tIns="0" bIns="0">
+            <a:spAutoFit/>
+          </a:bodyPr>
+          <a:lstStyle/>
+          <a:p>
+            <a:pPr algn="l"/>
+            <a:r>
+              <a:rPr sz="1300" b="0" i="0">
+                <a:solidFill>
+                  <a:srgbClr val="1A1A1A"/>
+                </a:solidFill>
+                <a:latin typeface="Microsoft YaHei"/>
+                <a:ea typeface="Microsoft YaHei"/>
+                <a:cs typeface="Microsoft YaHei"/>
+              </a:rPr>
+              <a:t>evals 集守护质量</a:t>
             </a:r>
           </a:p>
         </p:txBody>
@@ -4738,21 +4381,113 @@
                 <a:ea typeface="Microsoft YaHei"/>
                 <a:cs typeface="Microsoft YaHei"/>
               </a:rPr>
-              <a:t>技术方案</a:t>
-            </a:r>
-          </a:p>
-        </p:txBody>
-      </p:sp>
-      <p:sp>
-        <p:nvSpPr>
-          <p:cNvPr id="3" name="TextBox 2"/>
+              <a:t>v1 vs v2</a:t>
+            </a:r>
+          </a:p>
+        </p:txBody>
+      </p:sp>
+      <p:sp>
+        <p:nvSpPr>
+          <p:cNvPr id="3" name="Rounded Rectangle 2"/>
+          <p:cNvSpPr/>
+          <p:nvPr/>
+        </p:nvSpPr>
+        <p:spPr>
+          <a:xfrm>
+            <a:off x="502920" y="1280160"/>
+            <a:ext cx="5455767" cy="5120640"/>
+          </a:xfrm>
+          <a:prstGeom prst="roundRect">
+            <a:avLst>
+              <a:gd name="adj" fmla="val 5000"/>
+            </a:avLst>
+          </a:prstGeom>
+          <a:solidFill>
+            <a:srgbClr val="FFFFFF"/>
+          </a:solidFill>
+          <a:ln w="9525">
+            <a:solidFill>
+              <a:srgbClr val="D9D9D9"/>
+            </a:solidFill>
+          </a:ln>
+        </p:spPr>
+        <p:style>
+          <a:lnRef idx="1">
+            <a:schemeClr val="accent1"/>
+          </a:lnRef>
+          <a:fillRef idx="3">
+            <a:schemeClr val="accent1"/>
+          </a:fillRef>
+          <a:effectRef idx="2">
+            <a:schemeClr val="accent1"/>
+          </a:effectRef>
+          <a:fontRef idx="minor">
+            <a:schemeClr val="lt1"/>
+          </a:fontRef>
+        </p:style>
+        <p:txBody>
+          <a:bodyPr rtlCol="0" anchor="ctr"/>
+          <a:lstStyle/>
+          <a:p>
+            <a:pPr algn="ctr"/>
+          </a:p>
+        </p:txBody>
+      </p:sp>
+      <p:sp>
+        <p:nvSpPr>
+          <p:cNvPr id="4" name="Rounded Rectangle 3"/>
+          <p:cNvSpPr/>
+          <p:nvPr/>
+        </p:nvSpPr>
+        <p:spPr>
+          <a:xfrm>
+            <a:off x="502920" y="1280160"/>
+            <a:ext cx="36576" cy="5120640"/>
+          </a:xfrm>
+          <a:prstGeom prst="roundRect">
+            <a:avLst>
+              <a:gd name="adj" fmla="val 5000"/>
+            </a:avLst>
+          </a:prstGeom>
+          <a:solidFill>
+            <a:srgbClr val="1E6FE0"/>
+          </a:solidFill>
+          <a:ln>
+            <a:noFill/>
+          </a:ln>
+        </p:spPr>
+        <p:style>
+          <a:lnRef idx="1">
+            <a:schemeClr val="accent1"/>
+          </a:lnRef>
+          <a:fillRef idx="3">
+            <a:schemeClr val="accent1"/>
+          </a:fillRef>
+          <a:effectRef idx="2">
+            <a:schemeClr val="accent1"/>
+          </a:effectRef>
+          <a:fontRef idx="minor">
+            <a:schemeClr val="lt1"/>
+          </a:fontRef>
+        </p:style>
+        <p:txBody>
+          <a:bodyPr rtlCol="0" anchor="ctr"/>
+          <a:lstStyle/>
+          <a:p>
+            <a:pPr algn="ctr"/>
+          </a:p>
+        </p:txBody>
+      </p:sp>
+      <p:sp>
+        <p:nvSpPr>
+          <p:cNvPr id="5" name="TextBox 4"/>
           <p:cNvSpPr txBox="1"/>
           <p:nvPr/>
         </p:nvSpPr>
         <p:spPr>
           <a:xfrm>
-            <a:off x="502920" y="1645920"/>
-            <a:ext cx="11155680" cy="4754880"/>
+            <a:off x="777240" y="1508760"/>
+            <a:ext cx="4907127" cy="457200"/>
           </a:xfrm>
           <a:prstGeom prst="rect">
             <a:avLst/>
@@ -4765,24 +4500,46 @@
           </a:bodyPr>
           <a:lstStyle/>
           <a:p>
-            <a:pPr>
-              <a:lnSpc>
-                <a:spcPct val="145000"/>
-              </a:lnSpc>
-            </a:pPr>
-            <a:r>
-              <a:rPr sz="1600" b="1" i="0">
-                <a:solidFill>
-                  <a:srgbClr val="1E6FE0"/>
+            <a:pPr algn="l"/>
+            <a:r>
+              <a:rPr sz="1800" b="1" i="0">
+                <a:solidFill>
+                  <a:srgbClr val="0B2A4A"/>
                 </a:solidFill>
                 <a:latin typeface="Microsoft YaHei"/>
                 <a:ea typeface="Microsoft YaHei"/>
                 <a:cs typeface="Microsoft YaHei"/>
               </a:rPr>
-              <a:t>▎ </a:t>
-            </a:r>
-            <a:r>
-              <a:rPr sz="1600" b="0" i="0">
+              <a:t>v1</a:t>
+            </a:r>
+          </a:p>
+        </p:txBody>
+      </p:sp>
+      <p:sp>
+        <p:nvSpPr>
+          <p:cNvPr id="6" name="TextBox 5"/>
+          <p:cNvSpPr txBox="1"/>
+          <p:nvPr/>
+        </p:nvSpPr>
+        <p:spPr>
+          <a:xfrm>
+            <a:off x="777240" y="2103120"/>
+            <a:ext cx="4907127" cy="1828800"/>
+          </a:xfrm>
+          <a:prstGeom prst="rect">
+            <a:avLst/>
+          </a:prstGeom>
+          <a:noFill/>
+        </p:spPr>
+        <p:txBody>
+          <a:bodyPr wrap="square" lIns="0" rIns="0" tIns="0" bIns="0">
+            <a:spAutoFit/>
+          </a:bodyPr>
+          <a:lstStyle/>
+          <a:p>
+            <a:pPr algn="l"/>
+            <a:r>
+              <a:rPr sz="1300" b="0" i="0">
                 <a:solidFill>
                   <a:srgbClr val="1A1A1A"/>
                 </a:solidFill>
@@ -4790,28 +4547,165 @@
                 <a:ea typeface="Microsoft YaHei"/>
                 <a:cs typeface="Microsoft YaHei"/>
               </a:rPr>
-              <a:t>5 分钟生成一份完整 deck</a:t>
-            </a:r>
-          </a:p>
-          <a:p>
-            <a:pPr>
-              <a:lnSpc>
-                <a:spcPct val="145000"/>
-              </a:lnSpc>
-            </a:pPr>
-            <a:r>
-              <a:rPr sz="1600" b="1" i="0">
-                <a:solidFill>
-                  <a:srgbClr val="1E6FE0"/>
+              <a:t>骑墙,占位骨架</a:t>
+            </a:r>
+          </a:p>
+        </p:txBody>
+      </p:sp>
+      <p:sp>
+        <p:nvSpPr>
+          <p:cNvPr id="7" name="Rounded Rectangle 6"/>
+          <p:cNvSpPr/>
+          <p:nvPr/>
+        </p:nvSpPr>
+        <p:spPr>
+          <a:xfrm>
+            <a:off x="6233007" y="1280160"/>
+            <a:ext cx="5455767" cy="5120640"/>
+          </a:xfrm>
+          <a:prstGeom prst="roundRect">
+            <a:avLst>
+              <a:gd name="adj" fmla="val 5000"/>
+            </a:avLst>
+          </a:prstGeom>
+          <a:solidFill>
+            <a:srgbClr val="FFFFFF"/>
+          </a:solidFill>
+          <a:ln w="9525">
+            <a:solidFill>
+              <a:srgbClr val="D9D9D9"/>
+            </a:solidFill>
+          </a:ln>
+        </p:spPr>
+        <p:style>
+          <a:lnRef idx="1">
+            <a:schemeClr val="accent1"/>
+          </a:lnRef>
+          <a:fillRef idx="3">
+            <a:schemeClr val="accent1"/>
+          </a:fillRef>
+          <a:effectRef idx="2">
+            <a:schemeClr val="accent1"/>
+          </a:effectRef>
+          <a:fontRef idx="minor">
+            <a:schemeClr val="lt1"/>
+          </a:fontRef>
+        </p:style>
+        <p:txBody>
+          <a:bodyPr rtlCol="0" anchor="ctr"/>
+          <a:lstStyle/>
+          <a:p>
+            <a:pPr algn="ctr"/>
+          </a:p>
+        </p:txBody>
+      </p:sp>
+      <p:sp>
+        <p:nvSpPr>
+          <p:cNvPr id="8" name="Rounded Rectangle 7"/>
+          <p:cNvSpPr/>
+          <p:nvPr/>
+        </p:nvSpPr>
+        <p:spPr>
+          <a:xfrm>
+            <a:off x="6233007" y="1280160"/>
+            <a:ext cx="36576" cy="5120640"/>
+          </a:xfrm>
+          <a:prstGeom prst="roundRect">
+            <a:avLst>
+              <a:gd name="adj" fmla="val 5000"/>
+            </a:avLst>
+          </a:prstGeom>
+          <a:solidFill>
+            <a:srgbClr val="00D1C1"/>
+          </a:solidFill>
+          <a:ln>
+            <a:noFill/>
+          </a:ln>
+        </p:spPr>
+        <p:style>
+          <a:lnRef idx="1">
+            <a:schemeClr val="accent1"/>
+          </a:lnRef>
+          <a:fillRef idx="3">
+            <a:schemeClr val="accent1"/>
+          </a:fillRef>
+          <a:effectRef idx="2">
+            <a:schemeClr val="accent1"/>
+          </a:effectRef>
+          <a:fontRef idx="minor">
+            <a:schemeClr val="lt1"/>
+          </a:fontRef>
+        </p:style>
+        <p:txBody>
+          <a:bodyPr rtlCol="0" anchor="ctr"/>
+          <a:lstStyle/>
+          <a:p>
+            <a:pPr algn="ctr"/>
+          </a:p>
+        </p:txBody>
+      </p:sp>
+      <p:sp>
+        <p:nvSpPr>
+          <p:cNvPr id="9" name="TextBox 8"/>
+          <p:cNvSpPr txBox="1"/>
+          <p:nvPr/>
+        </p:nvSpPr>
+        <p:spPr>
+          <a:xfrm>
+            <a:off x="6507327" y="1508760"/>
+            <a:ext cx="4907127" cy="457200"/>
+          </a:xfrm>
+          <a:prstGeom prst="rect">
+            <a:avLst/>
+          </a:prstGeom>
+          <a:noFill/>
+        </p:spPr>
+        <p:txBody>
+          <a:bodyPr wrap="square" lIns="0" rIns="0" tIns="0" bIns="0">
+            <a:spAutoFit/>
+          </a:bodyPr>
+          <a:lstStyle/>
+          <a:p>
+            <a:pPr algn="l"/>
+            <a:r>
+              <a:rPr sz="1800" b="1" i="0">
+                <a:solidFill>
+                  <a:srgbClr val="0B2A4A"/>
                 </a:solidFill>
                 <a:latin typeface="Microsoft YaHei"/>
                 <a:ea typeface="Microsoft YaHei"/>
                 <a:cs typeface="Microsoft YaHei"/>
               </a:rPr>
-              <a:t>▎ </a:t>
-            </a:r>
-            <a:r>
-              <a:rPr sz="1600" b="0" i="0">
+              <a:t>v2</a:t>
+            </a:r>
+          </a:p>
+        </p:txBody>
+      </p:sp>
+      <p:sp>
+        <p:nvSpPr>
+          <p:cNvPr id="10" name="TextBox 9"/>
+          <p:cNvSpPr txBox="1"/>
+          <p:nvPr/>
+        </p:nvSpPr>
+        <p:spPr>
+          <a:xfrm>
+            <a:off x="6507327" y="2103120"/>
+            <a:ext cx="4907127" cy="1828800"/>
+          </a:xfrm>
+          <a:prstGeom prst="rect">
+            <a:avLst/>
+          </a:prstGeom>
+          <a:noFill/>
+        </p:spPr>
+        <p:txBody>
+          <a:bodyPr wrap="square" lIns="0" rIns="0" tIns="0" bIns="0">
+            <a:spAutoFit/>
+          </a:bodyPr>
+          <a:lstStyle/>
+          <a:p>
+            <a:pPr algn="l"/>
+            <a:r>
+              <a:rPr sz="1300" b="0" i="0">
                 <a:solidFill>
                   <a:srgbClr val="1A1A1A"/>
                 </a:solidFill>
@@ -4819,36 +4713,7 @@
                 <a:ea typeface="Microsoft YaHei"/>
                 <a:cs typeface="Microsoft YaHei"/>
               </a:rPr>
-              <a:t>视觉自检 + 自动修复</a:t>
-            </a:r>
-          </a:p>
-          <a:p>
-            <a:pPr>
-              <a:lnSpc>
-                <a:spcPct val="145000"/>
-              </a:lnSpc>
-            </a:pPr>
-            <a:r>
-              <a:rPr sz="1600" b="1" i="0">
-                <a:solidFill>
-                  <a:srgbClr val="1E6FE0"/>
-                </a:solidFill>
-                <a:latin typeface="Microsoft YaHei"/>
-                <a:ea typeface="Microsoft YaHei"/>
-                <a:cs typeface="Microsoft YaHei"/>
-              </a:rPr>
-              <a:t>▎ </a:t>
-            </a:r>
-            <a:r>
-              <a:rPr sz="1600" b="0" i="0">
-                <a:solidFill>
-                  <a:srgbClr val="1A1A1A"/>
-                </a:solidFill>
-                <a:latin typeface="Microsoft YaHei"/>
-                <a:ea typeface="Microsoft YaHei"/>
-                <a:cs typeface="Microsoft YaHei"/>
-              </a:rPr>
-              <a:t>支持模板学风格</a:t>
+              <a:t>诚实,机械/智能分离</a:t>
             </a:r>
           </a:p>
         </p:txBody>
@@ -4873,20 +4738,56 @@
       <p:grpSpPr/>
       <p:sp>
         <p:nvSpPr>
-          <p:cNvPr id="2" name="Rectangle 1"/>
+          <p:cNvPr id="2" name="TextBox 1"/>
+          <p:cNvSpPr txBox="1"/>
+          <p:nvPr/>
+        </p:nvSpPr>
+        <p:spPr>
+          <a:xfrm>
+            <a:off x="502920" y="548640"/>
+            <a:ext cx="11155680" cy="731520"/>
+          </a:xfrm>
+          <a:prstGeom prst="rect">
+            <a:avLst/>
+          </a:prstGeom>
+          <a:noFill/>
+        </p:spPr>
+        <p:txBody>
+          <a:bodyPr wrap="none" lIns="0" rIns="0" tIns="0" bIns="0">
+            <a:spAutoFit/>
+          </a:bodyPr>
+          <a:lstStyle/>
+          <a:p>
+            <a:r>
+              <a:rPr sz="3200" b="1" i="0">
+                <a:solidFill>
+                  <a:srgbClr val="0B2A4A"/>
+                </a:solidFill>
+                <a:latin typeface="Microsoft YaHei"/>
+                <a:ea typeface="Microsoft YaHei"/>
+                <a:cs typeface="Microsoft YaHei"/>
+              </a:rPr>
+              <a:t>核心结论</a:t>
+            </a:r>
+          </a:p>
+        </p:txBody>
+      </p:sp>
+      <p:sp>
+        <p:nvSpPr>
+          <p:cNvPr id="3" name="Rectangle 2"/>
           <p:cNvSpPr/>
           <p:nvPr/>
         </p:nvSpPr>
         <p:spPr>
           <a:xfrm>
-            <a:off x="502920" y="1737360"/>
-            <a:ext cx="1554480" cy="1828800"/>
+            <a:off x="502920" y="1280160"/>
+            <a:ext cx="822960" cy="1584960"/>
           </a:xfrm>
           <a:prstGeom prst="rect">
             <a:avLst/>
           </a:prstGeom>
           <a:solidFill>
-            <a:srgbClr val="0B2A4A"/>
+            <a:srgbClr val="1E6FE0"/>
           </a:solidFill>
           <a:ln>
             <a:noFill/>
@@ -4916,14 +4817,14 @@
       </p:sp>
       <p:sp>
         <p:nvSpPr>
-          <p:cNvPr id="3" name="TextBox 2"/>
+          <p:cNvPr id="4" name="TextBox 3"/>
           <p:cNvSpPr txBox="1"/>
           <p:nvPr/>
         </p:nvSpPr>
         <p:spPr>
           <a:xfrm>
-            <a:off x="502920" y="1737360"/>
-            <a:ext cx="1554480" cy="1828800"/>
+            <a:off x="502920" y="1280160"/>
+            <a:ext cx="822960" cy="1584960"/>
           </a:xfrm>
           <a:prstGeom prst="rect">
             <a:avLst/>
@@ -4938,7 +4839,239 @@
           <a:p>
             <a:pPr algn="ctr"/>
             <a:r>
-              <a:rPr sz="8000" b="1" i="0">
+              <a:rPr sz="3200" b="1" i="0">
+                <a:solidFill>
+                  <a:srgbClr val="FFFFFF"/>
+                </a:solidFill>
+                <a:latin typeface="Helvetica Neue"/>
+                <a:ea typeface="Helvetica Neue"/>
+                <a:cs typeface="Helvetica Neue"/>
+              </a:rPr>
+              <a:t>1</a:t>
+            </a:r>
+          </a:p>
+        </p:txBody>
+      </p:sp>
+      <p:sp>
+        <p:nvSpPr>
+          <p:cNvPr id="5" name="TextBox 4"/>
+          <p:cNvSpPr txBox="1"/>
+          <p:nvPr/>
+        </p:nvSpPr>
+        <p:spPr>
+          <a:xfrm>
+            <a:off x="1554480" y="1280160"/>
+            <a:ext cx="10134295" cy="1584960"/>
+          </a:xfrm>
+          <a:prstGeom prst="rect">
+            <a:avLst/>
+          </a:prstGeom>
+          <a:noFill/>
+        </p:spPr>
+        <p:txBody>
+          <a:bodyPr wrap="none" lIns="0" rIns="0" tIns="0" bIns="0">
+            <a:spAutoFit/>
+          </a:bodyPr>
+          <a:lstStyle/>
+          <a:p>
+            <a:r>
+              <a:rPr sz="1800" b="0" i="0">
+                <a:solidFill>
+                  <a:srgbClr val="1A1A1A"/>
+                </a:solidFill>
+                <a:latin typeface="Microsoft YaHei"/>
+                <a:ea typeface="Microsoft YaHei"/>
+                <a:cs typeface="Microsoft YaHei"/>
+              </a:rPr>
+              <a:t>接口诚实</a:t>
+            </a:r>
+          </a:p>
+        </p:txBody>
+      </p:sp>
+      <p:sp>
+        <p:nvSpPr>
+          <p:cNvPr id="6" name="Rectangle 5"/>
+          <p:cNvSpPr/>
+          <p:nvPr/>
+        </p:nvSpPr>
+        <p:spPr>
+          <a:xfrm>
+            <a:off x="502920" y="3048000"/>
+            <a:ext cx="822960" cy="1584960"/>
+          </a:xfrm>
+          <a:prstGeom prst="rect">
+            <a:avLst/>
+          </a:prstGeom>
+          <a:solidFill>
+            <a:srgbClr val="1E6FE0"/>
+          </a:solidFill>
+          <a:ln>
+            <a:noFill/>
+          </a:ln>
+        </p:spPr>
+        <p:style>
+          <a:lnRef idx="1">
+            <a:schemeClr val="accent1"/>
+          </a:lnRef>
+          <a:fillRef idx="3">
+            <a:schemeClr val="accent1"/>
+          </a:fillRef>
+          <a:effectRef idx="2">
+            <a:schemeClr val="accent1"/>
+          </a:effectRef>
+          <a:fontRef idx="minor">
+            <a:schemeClr val="lt1"/>
+          </a:fontRef>
+        </p:style>
+        <p:txBody>
+          <a:bodyPr rtlCol="0" anchor="ctr"/>
+          <a:lstStyle/>
+          <a:p>
+            <a:pPr algn="ctr"/>
+          </a:p>
+        </p:txBody>
+      </p:sp>
+      <p:sp>
+        <p:nvSpPr>
+          <p:cNvPr id="7" name="TextBox 6"/>
+          <p:cNvSpPr txBox="1"/>
+          <p:nvPr/>
+        </p:nvSpPr>
+        <p:spPr>
+          <a:xfrm>
+            <a:off x="502920" y="3048000"/>
+            <a:ext cx="822960" cy="1584960"/>
+          </a:xfrm>
+          <a:prstGeom prst="rect">
+            <a:avLst/>
+          </a:prstGeom>
+          <a:noFill/>
+        </p:spPr>
+        <p:txBody>
+          <a:bodyPr wrap="none" lIns="0" rIns="0" tIns="0" bIns="0">
+            <a:spAutoFit/>
+          </a:bodyPr>
+          <a:lstStyle/>
+          <a:p>
+            <a:pPr algn="ctr"/>
+            <a:r>
+              <a:rPr sz="3200" b="1" i="0">
+                <a:solidFill>
+                  <a:srgbClr val="FFFFFF"/>
+                </a:solidFill>
+                <a:latin typeface="Helvetica Neue"/>
+                <a:ea typeface="Helvetica Neue"/>
+                <a:cs typeface="Helvetica Neue"/>
+              </a:rPr>
+              <a:t>2</a:t>
+            </a:r>
+          </a:p>
+        </p:txBody>
+      </p:sp>
+      <p:sp>
+        <p:nvSpPr>
+          <p:cNvPr id="8" name="TextBox 7"/>
+          <p:cNvSpPr txBox="1"/>
+          <p:nvPr/>
+        </p:nvSpPr>
+        <p:spPr>
+          <a:xfrm>
+            <a:off x="1554480" y="3048000"/>
+            <a:ext cx="10134295" cy="1584960"/>
+          </a:xfrm>
+          <a:prstGeom prst="rect">
+            <a:avLst/>
+          </a:prstGeom>
+          <a:noFill/>
+        </p:spPr>
+        <p:txBody>
+          <a:bodyPr wrap="none" lIns="0" rIns="0" tIns="0" bIns="0">
+            <a:spAutoFit/>
+          </a:bodyPr>
+          <a:lstStyle/>
+          <a:p>
+            <a:r>
+              <a:rPr sz="1800" b="0" i="0">
+                <a:solidFill>
+                  <a:srgbClr val="1A1A1A"/>
+                </a:solidFill>
+                <a:latin typeface="Microsoft YaHei"/>
+                <a:ea typeface="Microsoft YaHei"/>
+                <a:cs typeface="Microsoft YaHei"/>
+              </a:rPr>
+              <a:t>布局可组合</a:t>
+            </a:r>
+          </a:p>
+        </p:txBody>
+      </p:sp>
+      <p:sp>
+        <p:nvSpPr>
+          <p:cNvPr id="9" name="Rectangle 8"/>
+          <p:cNvSpPr/>
+          <p:nvPr/>
+        </p:nvSpPr>
+        <p:spPr>
+          <a:xfrm>
+            <a:off x="502920" y="4815840"/>
+            <a:ext cx="822960" cy="1584960"/>
+          </a:xfrm>
+          <a:prstGeom prst="rect">
+            <a:avLst/>
+          </a:prstGeom>
+          <a:solidFill>
+            <a:srgbClr val="1E6FE0"/>
+          </a:solidFill>
+          <a:ln>
+            <a:noFill/>
+          </a:ln>
+        </p:spPr>
+        <p:style>
+          <a:lnRef idx="1">
+            <a:schemeClr val="accent1"/>
+          </a:lnRef>
+          <a:fillRef idx="3">
+            <a:schemeClr val="accent1"/>
+          </a:fillRef>
+          <a:effectRef idx="2">
+            <a:schemeClr val="accent1"/>
+          </a:effectRef>
+          <a:fontRef idx="minor">
+            <a:schemeClr val="lt1"/>
+          </a:fontRef>
+        </p:style>
+        <p:txBody>
+          <a:bodyPr rtlCol="0" anchor="ctr"/>
+          <a:lstStyle/>
+          <a:p>
+            <a:pPr algn="ctr"/>
+          </a:p>
+        </p:txBody>
+      </p:sp>
+      <p:sp>
+        <p:nvSpPr>
+          <p:cNvPr id="10" name="TextBox 9"/>
+          <p:cNvSpPr txBox="1"/>
+          <p:nvPr/>
+        </p:nvSpPr>
+        <p:spPr>
+          <a:xfrm>
+            <a:off x="502920" y="4815840"/>
+            <a:ext cx="822960" cy="1584960"/>
+          </a:xfrm>
+          <a:prstGeom prst="rect">
+            <a:avLst/>
+          </a:prstGeom>
+          <a:noFill/>
+        </p:spPr>
+        <p:txBody>
+          <a:bodyPr wrap="none" lIns="0" rIns="0" tIns="0" bIns="0">
+            <a:spAutoFit/>
+          </a:bodyPr>
+          <a:lstStyle/>
+          <a:p>
+            <a:pPr algn="ctr"/>
+            <a:r>
+              <a:rPr sz="3200" b="1" i="0">
                 <a:solidFill>
                   <a:srgbClr val="FFFFFF"/>
                 </a:solidFill>
@@ -4953,14 +5086,14 @@
       </p:sp>
       <p:sp>
         <p:nvSpPr>
-          <p:cNvPr id="4" name="TextBox 3"/>
+          <p:cNvPr id="11" name="TextBox 10"/>
           <p:cNvSpPr txBox="1"/>
           <p:nvPr/>
         </p:nvSpPr>
         <p:spPr>
           <a:xfrm>
-            <a:off x="2331720" y="2103120"/>
-            <a:ext cx="9144000" cy="1097280"/>
+            <a:off x="1554480" y="4815840"/>
+            <a:ext cx="10134295" cy="1584960"/>
           </a:xfrm>
           <a:prstGeom prst="rect">
             <a:avLst/>
@@ -4974,15 +5107,15 @@
           <a:lstStyle/>
           <a:p>
             <a:r>
-              <a:rPr sz="3600" b="1" i="0">
-                <a:solidFill>
-                  <a:srgbClr val="0B2A4A"/>
+              <a:rPr sz="1800" b="0" i="0">
+                <a:solidFill>
+                  <a:srgbClr val="1A1A1A"/>
                 </a:solidFill>
                 <a:latin typeface="Microsoft YaHei"/>
                 <a:ea typeface="Microsoft YaHei"/>
                 <a:cs typeface="Microsoft YaHei"/>
               </a:rPr>
-              <a:t>效果数据</a:t>
+              <a:t>质量可回归</a:t>
             </a:r>
           </a:p>
         </p:txBody>
@@ -5007,178 +5140,14 @@
       <p:grpSpPr/>
       <p:sp>
         <p:nvSpPr>
-          <p:cNvPr id="2" name="TextBox 1"/>
-          <p:cNvSpPr txBox="1"/>
-          <p:nvPr/>
-        </p:nvSpPr>
-        <p:spPr>
-          <a:xfrm>
-            <a:off x="502920" y="548640"/>
-            <a:ext cx="11155680" cy="731520"/>
-          </a:xfrm>
-          <a:prstGeom prst="rect">
-            <a:avLst/>
-          </a:prstGeom>
-          <a:noFill/>
-        </p:spPr>
-        <p:txBody>
-          <a:bodyPr wrap="none" lIns="0" rIns="0" tIns="0" bIns="0">
-            <a:spAutoFit/>
-          </a:bodyPr>
-          <a:lstStyle/>
-          <a:p>
-            <a:r>
-              <a:rPr sz="2800" b="1" i="0">
-                <a:solidFill>
-                  <a:srgbClr val="0B2A4A"/>
-                </a:solidFill>
-                <a:latin typeface="Microsoft YaHei"/>
-                <a:ea typeface="Microsoft YaHei"/>
-                <a:cs typeface="Microsoft YaHei"/>
-              </a:rPr>
-              <a:t>效果数据</a:t>
-            </a:r>
-          </a:p>
-        </p:txBody>
-      </p:sp>
-      <p:sp>
-        <p:nvSpPr>
-          <p:cNvPr id="3" name="TextBox 2"/>
-          <p:cNvSpPr txBox="1"/>
-          <p:nvPr/>
-        </p:nvSpPr>
-        <p:spPr>
-          <a:xfrm>
-            <a:off x="502920" y="1645920"/>
-            <a:ext cx="11155680" cy="4754880"/>
-          </a:xfrm>
-          <a:prstGeom prst="rect">
-            <a:avLst/>
-          </a:prstGeom>
-          <a:noFill/>
-        </p:spPr>
-        <p:txBody>
-          <a:bodyPr wrap="square" lIns="0" rIns="0" tIns="0" bIns="0">
-            <a:spAutoFit/>
-          </a:bodyPr>
-          <a:lstStyle/>
-          <a:p>
-            <a:pPr>
-              <a:lnSpc>
-                <a:spcPct val="145000"/>
-              </a:lnSpc>
-            </a:pPr>
-            <a:r>
-              <a:rPr sz="1600" b="1" i="0">
-                <a:solidFill>
-                  <a:srgbClr val="1E6FE0"/>
-                </a:solidFill>
-                <a:latin typeface="Microsoft YaHei"/>
-                <a:ea typeface="Microsoft YaHei"/>
-                <a:cs typeface="Microsoft YaHei"/>
-              </a:rPr>
-              <a:t>▎ </a:t>
-            </a:r>
-            <a:r>
-              <a:rPr sz="1600" b="0" i="0">
-                <a:solidFill>
-                  <a:srgbClr val="1A1A1A"/>
-                </a:solidFill>
-                <a:latin typeface="Microsoft YaHei"/>
-                <a:ea typeface="Microsoft YaHei"/>
-                <a:cs typeface="Microsoft YaHei"/>
-              </a:rPr>
-              <a:t>5 分钟生成一份完整 deck</a:t>
-            </a:r>
-          </a:p>
-          <a:p>
-            <a:pPr>
-              <a:lnSpc>
-                <a:spcPct val="145000"/>
-              </a:lnSpc>
-            </a:pPr>
-            <a:r>
-              <a:rPr sz="1600" b="1" i="0">
-                <a:solidFill>
-                  <a:srgbClr val="1E6FE0"/>
-                </a:solidFill>
-                <a:latin typeface="Microsoft YaHei"/>
-                <a:ea typeface="Microsoft YaHei"/>
-                <a:cs typeface="Microsoft YaHei"/>
-              </a:rPr>
-              <a:t>▎ </a:t>
-            </a:r>
-            <a:r>
-              <a:rPr sz="1600" b="0" i="0">
-                <a:solidFill>
-                  <a:srgbClr val="1A1A1A"/>
-                </a:solidFill>
-                <a:latin typeface="Microsoft YaHei"/>
-                <a:ea typeface="Microsoft YaHei"/>
-                <a:cs typeface="Microsoft YaHei"/>
-              </a:rPr>
-              <a:t>视觉自检 + 自动修复</a:t>
-            </a:r>
-          </a:p>
-          <a:p>
-            <a:pPr>
-              <a:lnSpc>
-                <a:spcPct val="145000"/>
-              </a:lnSpc>
-            </a:pPr>
-            <a:r>
-              <a:rPr sz="1600" b="1" i="0">
-                <a:solidFill>
-                  <a:srgbClr val="1E6FE0"/>
-                </a:solidFill>
-                <a:latin typeface="Microsoft YaHei"/>
-                <a:ea typeface="Microsoft YaHei"/>
-                <a:cs typeface="Microsoft YaHei"/>
-              </a:rPr>
-              <a:t>▎ </a:t>
-            </a:r>
-            <a:r>
-              <a:rPr sz="1600" b="0" i="0">
-                <a:solidFill>
-                  <a:srgbClr val="1A1A1A"/>
-                </a:solidFill>
-                <a:latin typeface="Microsoft YaHei"/>
-                <a:ea typeface="Microsoft YaHei"/>
-                <a:cs typeface="Microsoft YaHei"/>
-              </a:rPr>
-              <a:t>支持模板学风格</a:t>
-            </a:r>
-          </a:p>
-        </p:txBody>
-      </p:sp>
-    </p:spTree>
-  </p:cSld>
-  <p:clrMapOvr>
-    <a:masterClrMapping/>
-  </p:clrMapOvr>
-</p:sld>
-</file>
-
-<file path=ppt/slides/slide9.xml><?xml version="1.0" encoding="utf-8"?>
-<p:sld xmlns:a="http://schemas.openxmlformats.org/drawingml/2006/main" xmlns:p="http://schemas.openxmlformats.org/presentationml/2006/main" xmlns:r="http://schemas.openxmlformats.org/officeDocument/2006/relationships">
-  <p:cSld>
-    <p:spTree>
-      <p:nvGrpSpPr>
-        <p:cNvPr id="1" name=""/>
-        <p:cNvGrpSpPr/>
-        <p:nvPr/>
-      </p:nvGrpSpPr>
-      <p:grpSpPr/>
-      <p:sp>
-        <p:nvSpPr>
           <p:cNvPr id="2" name="Rectangle 1"/>
           <p:cNvSpPr/>
           <p:nvPr/>
         </p:nvSpPr>
         <p:spPr>
           <a:xfrm>
-            <a:off x="502920" y="1737360"/>
-            <a:ext cx="1554480" cy="1828800"/>
+            <a:off x="0" y="0"/>
+            <a:ext cx="12191695" cy="6858000"/>
           </a:xfrm>
           <a:prstGeom prst="rect">
             <a:avLst/>
@@ -5220,8 +5189,8 @@
         </p:nvSpPr>
         <p:spPr>
           <a:xfrm>
-            <a:off x="502920" y="1737360"/>
-            <a:ext cx="1554480" cy="1828800"/>
+            <a:off x="502920" y="2743200"/>
+            <a:ext cx="11185855" cy="1371600"/>
           </a:xfrm>
           <a:prstGeom prst="rect">
             <a:avLst/>
@@ -5229,22 +5198,22 @@
           <a:noFill/>
         </p:spPr>
         <p:txBody>
-          <a:bodyPr wrap="none" lIns="0" rIns="0" tIns="0" bIns="0">
+          <a:bodyPr wrap="square" lIns="0" rIns="0" tIns="0" bIns="0">
             <a:spAutoFit/>
           </a:bodyPr>
           <a:lstStyle/>
           <a:p>
             <a:pPr algn="ctr"/>
             <a:r>
-              <a:rPr sz="8000" b="1" i="0">
+              <a:rPr sz="6400" b="1" i="0">
                 <a:solidFill>
                   <a:srgbClr val="FFFFFF"/>
                 </a:solidFill>
-                <a:latin typeface="Helvetica Neue"/>
-                <a:ea typeface="Helvetica Neue"/>
-                <a:cs typeface="Helvetica Neue"/>
+                <a:latin typeface="Microsoft YaHei"/>
+                <a:ea typeface="Microsoft YaHei"/>
+                <a:cs typeface="Microsoft YaHei"/>
               </a:rPr>
-              <a:t>4</a:t>
+              <a:t>谢谢</a:t>
             </a:r>
           </a:p>
         </p:txBody>
@@ -5257,8 +5226,8 @@
         </p:nvSpPr>
         <p:spPr>
           <a:xfrm>
-            <a:off x="2331720" y="2103120"/>
-            <a:ext cx="9144000" cy="1097280"/>
+            <a:off x="502920" y="4389120"/>
+            <a:ext cx="11185855" cy="548640"/>
           </a:xfrm>
           <a:prstGeom prst="rect">
             <a:avLst/>
@@ -5266,21 +5235,22 @@
           <a:noFill/>
         </p:spPr>
         <p:txBody>
-          <a:bodyPr wrap="none" lIns="0" rIns="0" tIns="0" bIns="0">
+          <a:bodyPr wrap="square" lIns="0" rIns="0" tIns="0" bIns="0">
             <a:spAutoFit/>
           </a:bodyPr>
           <a:lstStyle/>
           <a:p>
-            <a:r>
-              <a:rPr sz="3600" b="1" i="0">
-                <a:solidFill>
-                  <a:srgbClr val="0B2A4A"/>
+            <a:pPr algn="ctr"/>
+            <a:r>
+              <a:rPr sz="1600" b="0" i="0">
+                <a:solidFill>
+                  <a:srgbClr val="E6F0FC"/>
                 </a:solidFill>
                 <a:latin typeface="Microsoft YaHei"/>
                 <a:ea typeface="Microsoft YaHei"/>
                 <a:cs typeface="Microsoft YaHei"/>
               </a:rPr>
-              <a:t>落地路径</a:t>
+              <a:t>github.com/pcliangx/iLovePPT</a:t>
             </a:r>
           </a:p>
         </p:txBody>

</xml_diff>

<commit_message>
fix(pptx): add full_region for full-bleed slide centering
Add full_region() primitive to layout.py that spans the full slide height,
and switch make_cover/make_closing in tech_blue.py to use it instead of
content_region(), so content centers on the full slide rather than the
1.4"–7.0" header-content band.
</commit_message>
<xml_diff>
--- a/skills/pptx-deck/examples/sample_output.pptx
+++ b/skills/pptx-deck/examples/sample_output.pptx
@@ -3146,7 +3146,7 @@
         </p:nvSpPr>
         <p:spPr>
           <a:xfrm>
-            <a:off x="502920" y="2834640"/>
+            <a:off x="502920" y="2423160"/>
             <a:ext cx="11185855" cy="1097280"/>
           </a:xfrm>
           <a:prstGeom prst="rect">
@@ -3183,7 +3183,7 @@
         </p:nvSpPr>
         <p:spPr>
           <a:xfrm>
-            <a:off x="502920" y="4206240"/>
+            <a:off x="502920" y="3794760"/>
             <a:ext cx="11185855" cy="640080"/>
           </a:xfrm>
           <a:prstGeom prst="rect">
@@ -5189,7 +5189,7 @@
         </p:nvSpPr>
         <p:spPr>
           <a:xfrm>
-            <a:off x="502920" y="2743200"/>
+            <a:off x="502920" y="2331720"/>
             <a:ext cx="11185855" cy="1371600"/>
           </a:xfrm>
           <a:prstGeom prst="rect">
@@ -5226,7 +5226,7 @@
         </p:nvSpPr>
         <p:spPr>
           <a:xfrm>
-            <a:off x="502920" y="4389120"/>
+            <a:off x="502920" y="3977640"/>
             <a:ext cx="11185855" cy="548640"/>
           </a:xfrm>
           <a:prstGeom prst="rect">

</xml_diff>

<commit_message>
chore: untrack render artifacts, regenerate sample_output
</commit_message>
<xml_diff>
--- a/skills/pptx-deck/examples/sample_output.pptx
+++ b/skills/pptx-deck/examples/sample_output.pptx
@@ -3508,8 +3508,8 @@
         </p:nvSpPr>
         <p:spPr>
           <a:xfrm>
-            <a:off x="502920" y="1737360"/>
-            <a:ext cx="1554480" cy="1828800"/>
+            <a:off x="502920" y="2697480"/>
+            <a:ext cx="1463040" cy="1463040"/>
           </a:xfrm>
           <a:prstGeom prst="rect">
             <a:avLst/>
@@ -3551,8 +3551,8 @@
         </p:nvSpPr>
         <p:spPr>
           <a:xfrm>
-            <a:off x="502920" y="1737360"/>
-            <a:ext cx="1554480" cy="1828800"/>
+            <a:off x="502920" y="2697480"/>
+            <a:ext cx="1463040" cy="1463040"/>
           </a:xfrm>
           <a:prstGeom prst="rect">
             <a:avLst/>
@@ -3567,7 +3567,7 @@
           <a:p>
             <a:pPr algn="ctr"/>
             <a:r>
-              <a:rPr sz="8000" b="1" i="0">
+              <a:rPr sz="7200" b="1" i="0">
                 <a:solidFill>
                   <a:srgbClr val="FFFFFF"/>
                 </a:solidFill>
@@ -3588,8 +3588,8 @@
         </p:nvSpPr>
         <p:spPr>
           <a:xfrm>
-            <a:off x="2331720" y="2103120"/>
-            <a:ext cx="9144000" cy="1097280"/>
+            <a:off x="2423160" y="2697480"/>
+            <a:ext cx="9265615" cy="1463040"/>
           </a:xfrm>
           <a:prstGeom prst="rect">
             <a:avLst/>
@@ -3597,13 +3597,14 @@
           <a:noFill/>
         </p:spPr>
         <p:txBody>
-          <a:bodyPr wrap="none" lIns="0" rIns="0" tIns="0" bIns="0">
+          <a:bodyPr wrap="square" lIns="0" rIns="0" tIns="0" bIns="0">
             <a:spAutoFit/>
           </a:bodyPr>
           <a:lstStyle/>
           <a:p>
-            <a:r>
-              <a:rPr sz="3600" b="1" i="0">
+            <a:pPr algn="l"/>
+            <a:r>
+              <a:rPr sz="4000" b="1" i="0">
                 <a:solidFill>
                   <a:srgbClr val="0B2A4A"/>
                 </a:solidFill>
@@ -3842,8 +3843,8 @@
         </p:nvSpPr>
         <p:spPr>
           <a:xfrm>
-            <a:off x="502920" y="1280160"/>
-            <a:ext cx="3545738" cy="5120640"/>
+            <a:off x="502920" y="2286000"/>
+            <a:ext cx="3545738" cy="3108960"/>
           </a:xfrm>
           <a:prstGeom prst="roundRect">
             <a:avLst>
@@ -3889,8 +3890,8 @@
         </p:nvSpPr>
         <p:spPr>
           <a:xfrm>
-            <a:off x="502920" y="1280160"/>
-            <a:ext cx="36576" cy="5120640"/>
+            <a:off x="502920" y="2286000"/>
+            <a:ext cx="36576" cy="3108960"/>
           </a:xfrm>
           <a:prstGeom prst="roundRect">
             <a:avLst>
@@ -3934,7 +3935,7 @@
         </p:nvSpPr>
         <p:spPr>
           <a:xfrm>
-            <a:off x="777240" y="1508760"/>
+            <a:off x="777240" y="2514600"/>
             <a:ext cx="2997098" cy="457200"/>
           </a:xfrm>
           <a:prstGeom prst="rect">
@@ -3971,7 +3972,7 @@
         </p:nvSpPr>
         <p:spPr>
           <a:xfrm>
-            <a:off x="777240" y="2103120"/>
+            <a:off x="777240" y="3108960"/>
             <a:ext cx="2997098" cy="1828800"/>
           </a:xfrm>
           <a:prstGeom prst="rect">
@@ -4008,8 +4009,8 @@
         </p:nvSpPr>
         <p:spPr>
           <a:xfrm>
-            <a:off x="4322978" y="1280160"/>
-            <a:ext cx="3545738" cy="5120640"/>
+            <a:off x="4322978" y="2286000"/>
+            <a:ext cx="3545738" cy="3108960"/>
           </a:xfrm>
           <a:prstGeom prst="roundRect">
             <a:avLst>
@@ -4055,8 +4056,8 @@
         </p:nvSpPr>
         <p:spPr>
           <a:xfrm>
-            <a:off x="4322978" y="1280160"/>
-            <a:ext cx="36576" cy="5120640"/>
+            <a:off x="4322978" y="2286000"/>
+            <a:ext cx="36576" cy="3108960"/>
           </a:xfrm>
           <a:prstGeom prst="roundRect">
             <a:avLst>
@@ -4100,7 +4101,7 @@
         </p:nvSpPr>
         <p:spPr>
           <a:xfrm>
-            <a:off x="4597298" y="1508760"/>
+            <a:off x="4597298" y="2514600"/>
             <a:ext cx="2997098" cy="457200"/>
           </a:xfrm>
           <a:prstGeom prst="rect">
@@ -4137,7 +4138,7 @@
         </p:nvSpPr>
         <p:spPr>
           <a:xfrm>
-            <a:off x="4597298" y="2103120"/>
+            <a:off x="4597298" y="3108960"/>
             <a:ext cx="2997098" cy="1828800"/>
           </a:xfrm>
           <a:prstGeom prst="rect">
@@ -4174,8 +4175,8 @@
         </p:nvSpPr>
         <p:spPr>
           <a:xfrm>
-            <a:off x="8143036" y="1280160"/>
-            <a:ext cx="3545738" cy="5120640"/>
+            <a:off x="8143036" y="2286000"/>
+            <a:ext cx="3545738" cy="3108960"/>
           </a:xfrm>
           <a:prstGeom prst="roundRect">
             <a:avLst>
@@ -4221,8 +4222,8 @@
         </p:nvSpPr>
         <p:spPr>
           <a:xfrm>
-            <a:off x="8143036" y="1280160"/>
-            <a:ext cx="36576" cy="5120640"/>
+            <a:off x="8143036" y="2286000"/>
+            <a:ext cx="36576" cy="3108960"/>
           </a:xfrm>
           <a:prstGeom prst="roundRect">
             <a:avLst>
@@ -4266,7 +4267,7 @@
         </p:nvSpPr>
         <p:spPr>
           <a:xfrm>
-            <a:off x="8417356" y="1508760"/>
+            <a:off x="8417356" y="2514600"/>
             <a:ext cx="2997098" cy="457200"/>
           </a:xfrm>
           <a:prstGeom prst="rect">
@@ -4303,7 +4304,7 @@
         </p:nvSpPr>
         <p:spPr>
           <a:xfrm>
-            <a:off x="8417356" y="2103120"/>
+            <a:off x="8417356" y="3108960"/>
             <a:ext cx="2997098" cy="1828800"/>
           </a:xfrm>
           <a:prstGeom prst="rect">
@@ -4394,8 +4395,8 @@
         </p:nvSpPr>
         <p:spPr>
           <a:xfrm>
-            <a:off x="502920" y="1280160"/>
-            <a:ext cx="5455767" cy="5120640"/>
+            <a:off x="502920" y="2286000"/>
+            <a:ext cx="5455767" cy="3108960"/>
           </a:xfrm>
           <a:prstGeom prst="roundRect">
             <a:avLst>
@@ -4441,8 +4442,8 @@
         </p:nvSpPr>
         <p:spPr>
           <a:xfrm>
-            <a:off x="502920" y="1280160"/>
-            <a:ext cx="36576" cy="5120640"/>
+            <a:off x="502920" y="2286000"/>
+            <a:ext cx="36576" cy="3108960"/>
           </a:xfrm>
           <a:prstGeom prst="roundRect">
             <a:avLst>
@@ -4486,7 +4487,7 @@
         </p:nvSpPr>
         <p:spPr>
           <a:xfrm>
-            <a:off x="777240" y="1508760"/>
+            <a:off x="777240" y="2514600"/>
             <a:ext cx="4907127" cy="457200"/>
           </a:xfrm>
           <a:prstGeom prst="rect">
@@ -4523,7 +4524,7 @@
         </p:nvSpPr>
         <p:spPr>
           <a:xfrm>
-            <a:off x="777240" y="2103120"/>
+            <a:off x="777240" y="3108960"/>
             <a:ext cx="4907127" cy="1828800"/>
           </a:xfrm>
           <a:prstGeom prst="rect">
@@ -4560,8 +4561,8 @@
         </p:nvSpPr>
         <p:spPr>
           <a:xfrm>
-            <a:off x="6233007" y="1280160"/>
-            <a:ext cx="5455767" cy="5120640"/>
+            <a:off x="6233007" y="2286000"/>
+            <a:ext cx="5455767" cy="3108960"/>
           </a:xfrm>
           <a:prstGeom prst="roundRect">
             <a:avLst>
@@ -4607,8 +4608,8 @@
         </p:nvSpPr>
         <p:spPr>
           <a:xfrm>
-            <a:off x="6233007" y="1280160"/>
-            <a:ext cx="36576" cy="5120640"/>
+            <a:off x="6233007" y="2286000"/>
+            <a:ext cx="36576" cy="3108960"/>
           </a:xfrm>
           <a:prstGeom prst="roundRect">
             <a:avLst>
@@ -4652,7 +4653,7 @@
         </p:nvSpPr>
         <p:spPr>
           <a:xfrm>
-            <a:off x="6507327" y="1508760"/>
+            <a:off x="6507327" y="2514600"/>
             <a:ext cx="4907127" cy="457200"/>
           </a:xfrm>
           <a:prstGeom prst="rect">
@@ -4689,7 +4690,7 @@
         </p:nvSpPr>
         <p:spPr>
           <a:xfrm>
-            <a:off x="6507327" y="2103120"/>
+            <a:off x="6507327" y="3108960"/>
             <a:ext cx="4907127" cy="1828800"/>
           </a:xfrm>
           <a:prstGeom prst="rect">

</xml_diff>